<commit_message>
📰 Pulse update 2026-03-12
</commit_message>
<xml_diff>
--- a/data/archive/pulse_2026-03-12.pptx
+++ b/data/archive/pulse_2026-03-12.pptx
@@ -15,6 +15,15 @@
     <p:sldId id="263" r:id="rId14"/>
     <p:sldId id="264" r:id="rId15"/>
     <p:sldId id="265" r:id="rId16"/>
+    <p:sldId id="266" r:id="rId17"/>
+    <p:sldId id="267" r:id="rId18"/>
+    <p:sldId id="268" r:id="rId19"/>
+    <p:sldId id="269" r:id="rId20"/>
+    <p:sldId id="270" r:id="rId21"/>
+    <p:sldId id="271" r:id="rId22"/>
+    <p:sldId id="272" r:id="rId23"/>
+    <p:sldId id="273" r:id="rId24"/>
+    <p:sldId id="274" r:id="rId25"/>
   </p:sldIdLst>
   <p:sldSz cx="12191695" cy="6858000" type="screen4x3"/>
   <p:notesSz cx="6858000" cy="9144000"/>
@@ -3297,7 +3306,7 @@
             <a:avLst/>
           </a:prstGeom>
           <a:solidFill>
-            <a:srgbClr val="FF6B35"/>
+            <a:srgbClr val="E74C3C"/>
           </a:solidFill>
           <a:ln>
             <a:noFill/>
@@ -3350,13 +3359,13 @@
             <a:pPr algn="l">
               <a:defRPr sz="1000" b="1">
                 <a:solidFill>
-                  <a:srgbClr val="FF6B35"/>
-                </a:solidFill>
-                <a:latin typeface="Calibri"/>
-              </a:defRPr>
-            </a:pPr>
-            <a:r>
-              <a:t>🎊  WEEKLY RITUAL</a:t>
+                  <a:srgbClr val="E74C3C"/>
+                </a:solidFill>
+                <a:latin typeface="Calibri"/>
+              </a:defRPr>
+            </a:pPr>
+            <a:r>
+              <a:t>💪  CLAPS</a:t>
             </a:r>
           </a:p>
         </p:txBody>
@@ -3386,13 +3395,2581 @@
             <a:pPr algn="l">
               <a:defRPr sz="3200" b="1" i="0">
                 <a:solidFill>
-                  <a:srgbClr val="FF6B35"/>
-                </a:solidFill>
-                <a:latin typeface="Calibri"/>
-              </a:defRPr>
-            </a:pPr>
-            <a:r>
-              <a:t>Recognition Wave</a:t>
+                  <a:srgbClr val="E74C3C"/>
+                </a:solidFill>
+                <a:latin typeface="Calibri"/>
+              </a:defRPr>
+            </a:pPr>
+            <a:r>
+              <a:t>Multi-Team Recognition</a:t>
+            </a:r>
+          </a:p>
+        </p:txBody>
+      </p:sp>
+      <p:sp>
+        <p:nvSpPr>
+          <p:cNvPr id="5" name="TextBox 4"/>
+          <p:cNvSpPr txBox="1"/>
+          <p:nvPr/>
+        </p:nvSpPr>
+        <p:spPr>
+          <a:xfrm>
+            <a:off x="1097280" y="2103120"/>
+            <a:ext cx="2743200" cy="548640"/>
+          </a:xfrm>
+          <a:prstGeom prst="rect">
+            <a:avLst/>
+          </a:prstGeom>
+          <a:noFill/>
+        </p:spPr>
+        <p:txBody>
+          <a:bodyPr wrap="square">
+            <a:spAutoFit/>
+          </a:bodyPr>
+          <a:lstStyle/>
+          <a:p>
+            <a:pPr algn="l">
+              <a:defRPr sz="2800" b="1" i="0">
+                <a:solidFill>
+                  <a:srgbClr val="E74C3C"/>
+                </a:solidFill>
+                <a:latin typeface="Calibri"/>
+              </a:defRPr>
+            </a:pPr>
+            <a:r>
+              <a:t>8</a:t>
+            </a:r>
+          </a:p>
+        </p:txBody>
+      </p:sp>
+      <p:sp>
+        <p:nvSpPr>
+          <p:cNvPr id="6" name="TextBox 5"/>
+          <p:cNvSpPr txBox="1"/>
+          <p:nvPr/>
+        </p:nvSpPr>
+        <p:spPr>
+          <a:xfrm>
+            <a:off x="1097280" y="2651760"/>
+            <a:ext cx="9966960" cy="365760"/>
+          </a:xfrm>
+          <a:prstGeom prst="rect">
+            <a:avLst/>
+          </a:prstGeom>
+          <a:noFill/>
+        </p:spPr>
+        <p:txBody>
+          <a:bodyPr wrap="square">
+            <a:spAutoFit/>
+          </a:bodyPr>
+          <a:lstStyle/>
+          <a:p>
+            <a:pPr algn="l">
+              <a:defRPr sz="1400" b="0" i="0">
+                <a:solidFill>
+                  <a:srgbClr val="E2E2EA"/>
+                </a:solidFill>
+                <a:latin typeface="Calibri"/>
+              </a:defRPr>
+            </a:pPr>
+            <a:r>
+              <a:t>from Alexandr Zhitlukhin</a:t>
+            </a:r>
+          </a:p>
+        </p:txBody>
+      </p:sp>
+      <p:sp>
+        <p:nvSpPr>
+          <p:cNvPr id="7" name="TextBox 6"/>
+          <p:cNvSpPr txBox="1"/>
+          <p:nvPr/>
+        </p:nvSpPr>
+        <p:spPr>
+          <a:xfrm>
+            <a:off x="1097280" y="3108960"/>
+            <a:ext cx="9966960" cy="365760"/>
+          </a:xfrm>
+          <a:prstGeom prst="rect">
+            <a:avLst/>
+          </a:prstGeom>
+          <a:noFill/>
+        </p:spPr>
+        <p:txBody>
+          <a:bodyPr wrap="square">
+            <a:spAutoFit/>
+          </a:bodyPr>
+          <a:lstStyle/>
+          <a:p>
+            <a:pPr algn="l">
+              <a:defRPr sz="1400" b="1" i="0">
+                <a:solidFill>
+                  <a:srgbClr val="FFFFFF"/>
+                </a:solidFill>
+                <a:latin typeface="Calibri"/>
+              </a:defRPr>
+            </a:pPr>
+            <a:r>
+              <a:t>to: ArtKip, Taha, Agustin, Francesco, Alessandro, Anna Timoshenko</a:t>
+            </a:r>
+          </a:p>
+        </p:txBody>
+      </p:sp>
+      <p:sp>
+        <p:nvSpPr>
+          <p:cNvPr id="8" name="TextBox 7"/>
+          <p:cNvSpPr txBox="1"/>
+          <p:nvPr/>
+        </p:nvSpPr>
+        <p:spPr>
+          <a:xfrm>
+            <a:off x="1097280" y="3749039"/>
+            <a:ext cx="9966960" cy="1097280"/>
+          </a:xfrm>
+          <a:prstGeom prst="rect">
+            <a:avLst/>
+          </a:prstGeom>
+          <a:noFill/>
+        </p:spPr>
+        <p:txBody>
+          <a:bodyPr wrap="square">
+            <a:spAutoFit/>
+          </a:bodyPr>
+          <a:lstStyle/>
+          <a:p>
+            <a:pPr algn="l">
+              <a:defRPr sz="1500" b="0" i="1">
+                <a:solidFill>
+                  <a:srgbClr val="E2E2EA"/>
+                </a:solidFill>
+                <a:latin typeface="Calibri"/>
+              </a:defRPr>
+            </a:pPr>
+            <a:r>
+              <a:t>"Incredible cross-functional collaboration"</a:t>
+            </a:r>
+          </a:p>
+        </p:txBody>
+      </p:sp>
+      <p:sp>
+        <p:nvSpPr>
+          <p:cNvPr id="9" name="TextBox 8"/>
+          <p:cNvSpPr txBox="1"/>
+          <p:nvPr/>
+        </p:nvSpPr>
+        <p:spPr>
+          <a:xfrm>
+            <a:off x="1097280" y="5120640"/>
+            <a:ext cx="9966960" cy="457200"/>
+          </a:xfrm>
+          <a:prstGeom prst="rect">
+            <a:avLst/>
+          </a:prstGeom>
+          <a:noFill/>
+        </p:spPr>
+        <p:txBody>
+          <a:bodyPr wrap="square">
+            <a:spAutoFit/>
+          </a:bodyPr>
+          <a:lstStyle/>
+          <a:p>
+            <a:pPr algn="l">
+              <a:defRPr sz="1200" b="1" i="0">
+                <a:solidFill>
+                  <a:srgbClr val="E74C3C"/>
+                </a:solidFill>
+                <a:latin typeface="Calibri"/>
+              </a:defRPr>
+            </a:pPr>
+            <a:r>
+              <a:t>TEAMWORK · COLLABORATION</a:t>
+            </a:r>
+          </a:p>
+        </p:txBody>
+      </p:sp>
+    </p:spTree>
+  </p:cSld>
+  <p:clrMapOvr>
+    <a:masterClrMapping/>
+  </p:clrMapOvr>
+</p:sld>
+</file>
+
+<file path=ppt/slides/slide11.xml><?xml version="1.0" encoding="utf-8"?>
+<p:sld xmlns:a="http://schemas.openxmlformats.org/drawingml/2006/main" xmlns:p="http://schemas.openxmlformats.org/presentationml/2006/main" xmlns:r="http://schemas.openxmlformats.org/officeDocument/2006/relationships">
+  <p:cSld>
+    <p:bg>
+      <p:bgPr>
+        <a:solidFill>
+          <a:srgbClr val="08080C"/>
+        </a:solidFill>
+        <a:effectLst/>
+      </p:bgPr>
+    </p:bg>
+    <p:spTree>
+      <p:nvGrpSpPr>
+        <p:cNvPr id="1" name=""/>
+        <p:cNvGrpSpPr/>
+        <p:nvPr/>
+      </p:nvGrpSpPr>
+      <p:grpSpPr/>
+      <p:sp>
+        <p:nvSpPr>
+          <p:cNvPr id="2" name="Rectangle 1"/>
+          <p:cNvSpPr/>
+          <p:nvPr/>
+        </p:nvSpPr>
+        <p:spPr>
+          <a:xfrm>
+            <a:off x="0" y="365760"/>
+            <a:ext cx="12191695" cy="54864"/>
+          </a:xfrm>
+          <a:prstGeom prst="rect">
+            <a:avLst/>
+          </a:prstGeom>
+          <a:solidFill>
+            <a:srgbClr val="16A085"/>
+          </a:solidFill>
+          <a:ln>
+            <a:noFill/>
+          </a:ln>
+        </p:spPr>
+        <p:style>
+          <a:lnRef idx="1">
+            <a:schemeClr val="accent1"/>
+          </a:lnRef>
+          <a:fillRef idx="3">
+            <a:schemeClr val="accent1"/>
+          </a:fillRef>
+          <a:effectRef idx="2">
+            <a:schemeClr val="accent1"/>
+          </a:effectRef>
+          <a:fontRef idx="minor">
+            <a:schemeClr val="lt1"/>
+          </a:fontRef>
+        </p:style>
+        <p:txBody>
+          <a:bodyPr rtlCol="0" anchor="ctr"/>
+          <a:lstStyle/>
+          <a:p>
+            <a:pPr algn="ctr"/>
+          </a:p>
+        </p:txBody>
+      </p:sp>
+      <p:sp>
+        <p:nvSpPr>
+          <p:cNvPr id="3" name="TextBox 2"/>
+          <p:cNvSpPr txBox="1"/>
+          <p:nvPr/>
+        </p:nvSpPr>
+        <p:spPr>
+          <a:xfrm>
+            <a:off x="1097280" y="731520"/>
+            <a:ext cx="3657600" cy="365760"/>
+          </a:xfrm>
+          <a:prstGeom prst="rect">
+            <a:avLst/>
+          </a:prstGeom>
+          <a:noFill/>
+        </p:spPr>
+        <p:txBody>
+          <a:bodyPr wrap="none">
+            <a:spAutoFit/>
+          </a:bodyPr>
+          <a:lstStyle/>
+          <a:p>
+            <a:pPr algn="l">
+              <a:defRPr sz="1000" b="1">
+                <a:solidFill>
+                  <a:srgbClr val="16A085"/>
+                </a:solidFill>
+                <a:latin typeface="Calibri"/>
+              </a:defRPr>
+            </a:pPr>
+            <a:r>
+              <a:t>💰  MILESTONE</a:t>
+            </a:r>
+          </a:p>
+        </p:txBody>
+      </p:sp>
+      <p:sp>
+        <p:nvSpPr>
+          <p:cNvPr id="4" name="TextBox 3"/>
+          <p:cNvSpPr txBox="1"/>
+          <p:nvPr/>
+        </p:nvSpPr>
+        <p:spPr>
+          <a:xfrm>
+            <a:off x="1097280" y="1188720"/>
+            <a:ext cx="9966960" cy="731520"/>
+          </a:xfrm>
+          <a:prstGeom prst="rect">
+            <a:avLst/>
+          </a:prstGeom>
+          <a:noFill/>
+        </p:spPr>
+        <p:txBody>
+          <a:bodyPr wrap="square">
+            <a:spAutoFit/>
+          </a:bodyPr>
+          <a:lstStyle/>
+          <a:p>
+            <a:pPr algn="l">
+              <a:defRPr sz="3200" b="1" i="0">
+                <a:solidFill>
+                  <a:srgbClr val="16A085"/>
+                </a:solidFill>
+                <a:latin typeface="Calibri"/>
+              </a:defRPr>
+            </a:pPr>
+            <a:r>
+              <a:t>Revenue Milestone</a:t>
+            </a:r>
+          </a:p>
+        </p:txBody>
+      </p:sp>
+      <p:sp>
+        <p:nvSpPr>
+          <p:cNvPr id="5" name="TextBox 4"/>
+          <p:cNvSpPr txBox="1"/>
+          <p:nvPr/>
+        </p:nvSpPr>
+        <p:spPr>
+          <a:xfrm>
+            <a:off x="1097280" y="2103120"/>
+            <a:ext cx="4572000" cy="822960"/>
+          </a:xfrm>
+          <a:prstGeom prst="rect">
+            <a:avLst/>
+          </a:prstGeom>
+          <a:noFill/>
+        </p:spPr>
+        <p:txBody>
+          <a:bodyPr wrap="square">
+            <a:spAutoFit/>
+          </a:bodyPr>
+          <a:lstStyle/>
+          <a:p>
+            <a:pPr algn="l">
+              <a:defRPr sz="5200" b="1" i="0">
+                <a:solidFill>
+                  <a:srgbClr val="16A085"/>
+                </a:solidFill>
+                <a:latin typeface="Calibri"/>
+              </a:defRPr>
+            </a:pPr>
+            <a:r>
+              <a:t>$390k</a:t>
+            </a:r>
+          </a:p>
+        </p:txBody>
+      </p:sp>
+      <p:sp>
+        <p:nvSpPr>
+          <p:cNvPr id="6" name="TextBox 5"/>
+          <p:cNvSpPr txBox="1"/>
+          <p:nvPr/>
+        </p:nvSpPr>
+        <p:spPr>
+          <a:xfrm>
+            <a:off x="1097280" y="2926080"/>
+            <a:ext cx="4572000" cy="365760"/>
+          </a:xfrm>
+          <a:prstGeom prst="rect">
+            <a:avLst/>
+          </a:prstGeom>
+          <a:noFill/>
+        </p:spPr>
+        <p:txBody>
+          <a:bodyPr wrap="square">
+            <a:spAutoFit/>
+          </a:bodyPr>
+          <a:lstStyle/>
+          <a:p>
+            <a:pPr algn="l">
+              <a:defRPr sz="1100" b="0" i="0">
+                <a:solidFill>
+                  <a:srgbClr val="8F95A3"/>
+                </a:solidFill>
+                <a:latin typeface="Calibri"/>
+              </a:defRPr>
+            </a:pPr>
+            <a:r>
+              <a:t>Net Revenue (One Week)</a:t>
+            </a:r>
+          </a:p>
+        </p:txBody>
+      </p:sp>
+      <p:sp>
+        <p:nvSpPr>
+          <p:cNvPr id="7" name="TextBox 6"/>
+          <p:cNvSpPr txBox="1"/>
+          <p:nvPr/>
+        </p:nvSpPr>
+        <p:spPr>
+          <a:xfrm>
+            <a:off x="1097280" y="3566160"/>
+            <a:ext cx="9966960" cy="457200"/>
+          </a:xfrm>
+          <a:prstGeom prst="rect">
+            <a:avLst/>
+          </a:prstGeom>
+          <a:noFill/>
+        </p:spPr>
+        <p:txBody>
+          <a:bodyPr wrap="square">
+            <a:spAutoFit/>
+          </a:bodyPr>
+          <a:lstStyle/>
+          <a:p>
+            <a:pPr algn="l">
+              <a:defRPr sz="1800" b="1" i="0">
+                <a:solidFill>
+                  <a:srgbClr val="FFFFFF"/>
+                </a:solidFill>
+                <a:latin typeface="Calibri"/>
+              </a:defRPr>
+            </a:pPr>
+            <a:r>
+              <a:t>Weekly Sales Achievement</a:t>
+            </a:r>
+          </a:p>
+        </p:txBody>
+      </p:sp>
+      <p:sp>
+        <p:nvSpPr>
+          <p:cNvPr id="8" name="TextBox 7"/>
+          <p:cNvSpPr txBox="1"/>
+          <p:nvPr/>
+        </p:nvSpPr>
+        <p:spPr>
+          <a:xfrm>
+            <a:off x="1097280" y="4206240"/>
+            <a:ext cx="9966960" cy="1371600"/>
+          </a:xfrm>
+          <a:prstGeom prst="rect">
+            <a:avLst/>
+          </a:prstGeom>
+          <a:noFill/>
+        </p:spPr>
+        <p:txBody>
+          <a:bodyPr wrap="square">
+            <a:spAutoFit/>
+          </a:bodyPr>
+          <a:lstStyle/>
+          <a:p>
+            <a:pPr algn="l">
+              <a:defRPr sz="1500" b="0" i="0">
+                <a:solidFill>
+                  <a:srgbClr val="E2E2EA"/>
+                </a:solidFill>
+                <a:latin typeface="Calibri"/>
+              </a:defRPr>
+            </a:pPr>
+            <a:r>
+              <a:t>Exceptional performance across all revenue streams</a:t>
+            </a:r>
+          </a:p>
+        </p:txBody>
+      </p:sp>
+    </p:spTree>
+  </p:cSld>
+  <p:clrMapOvr>
+    <a:masterClrMapping/>
+  </p:clrMapOvr>
+</p:sld>
+</file>
+
+<file path=ppt/slides/slide12.xml><?xml version="1.0" encoding="utf-8"?>
+<p:sld xmlns:a="http://schemas.openxmlformats.org/drawingml/2006/main" xmlns:p="http://schemas.openxmlformats.org/presentationml/2006/main" xmlns:r="http://schemas.openxmlformats.org/officeDocument/2006/relationships">
+  <p:cSld>
+    <p:bg>
+      <p:bgPr>
+        <a:solidFill>
+          <a:srgbClr val="08080C"/>
+        </a:solidFill>
+        <a:effectLst/>
+      </p:bgPr>
+    </p:bg>
+    <p:spTree>
+      <p:nvGrpSpPr>
+        <p:cNvPr id="1" name=""/>
+        <p:cNvGrpSpPr/>
+        <p:nvPr/>
+      </p:nvGrpSpPr>
+      <p:grpSpPr/>
+      <p:sp>
+        <p:nvSpPr>
+          <p:cNvPr id="2" name="Rectangle 1"/>
+          <p:cNvSpPr/>
+          <p:nvPr/>
+        </p:nvSpPr>
+        <p:spPr>
+          <a:xfrm>
+            <a:off x="0" y="365760"/>
+            <a:ext cx="12191695" cy="54864"/>
+          </a:xfrm>
+          <a:prstGeom prst="rect">
+            <a:avLst/>
+          </a:prstGeom>
+          <a:solidFill>
+            <a:srgbClr val="C0392B"/>
+          </a:solidFill>
+          <a:ln>
+            <a:noFill/>
+          </a:ln>
+        </p:spPr>
+        <p:style>
+          <a:lnRef idx="1">
+            <a:schemeClr val="accent1"/>
+          </a:lnRef>
+          <a:fillRef idx="3">
+            <a:schemeClr val="accent1"/>
+          </a:fillRef>
+          <a:effectRef idx="2">
+            <a:schemeClr val="accent1"/>
+          </a:effectRef>
+          <a:fontRef idx="minor">
+            <a:schemeClr val="lt1"/>
+          </a:fontRef>
+        </p:style>
+        <p:txBody>
+          <a:bodyPr rtlCol="0" anchor="ctr"/>
+          <a:lstStyle/>
+          <a:p>
+            <a:pPr algn="ctr"/>
+          </a:p>
+        </p:txBody>
+      </p:sp>
+      <p:sp>
+        <p:nvSpPr>
+          <p:cNvPr id="3" name="TextBox 2"/>
+          <p:cNvSpPr txBox="1"/>
+          <p:nvPr/>
+        </p:nvSpPr>
+        <p:spPr>
+          <a:xfrm>
+            <a:off x="1097280" y="731520"/>
+            <a:ext cx="3657600" cy="365760"/>
+          </a:xfrm>
+          <a:prstGeom prst="rect">
+            <a:avLst/>
+          </a:prstGeom>
+          <a:noFill/>
+        </p:spPr>
+        <p:txBody>
+          <a:bodyPr wrap="none">
+            <a:spAutoFit/>
+          </a:bodyPr>
+          <a:lstStyle/>
+          <a:p>
+            <a:pPr algn="l">
+              <a:defRPr sz="1000" b="1">
+                <a:solidFill>
+                  <a:srgbClr val="C0392B"/>
+                </a:solidFill>
+                <a:latin typeface="Calibri"/>
+              </a:defRPr>
+            </a:pPr>
+            <a:r>
+              <a:t>🛡️  WIN</a:t>
+            </a:r>
+          </a:p>
+        </p:txBody>
+      </p:sp>
+      <p:sp>
+        <p:nvSpPr>
+          <p:cNvPr id="4" name="TextBox 3"/>
+          <p:cNvSpPr txBox="1"/>
+          <p:nvPr/>
+        </p:nvSpPr>
+        <p:spPr>
+          <a:xfrm>
+            <a:off x="1097280" y="1188720"/>
+            <a:ext cx="9966960" cy="731520"/>
+          </a:xfrm>
+          <a:prstGeom prst="rect">
+            <a:avLst/>
+          </a:prstGeom>
+          <a:noFill/>
+        </p:spPr>
+        <p:txBody>
+          <a:bodyPr wrap="square">
+            <a:spAutoFit/>
+          </a:bodyPr>
+          <a:lstStyle/>
+          <a:p>
+            <a:pPr algn="l">
+              <a:defRPr sz="3200" b="1" i="0">
+                <a:solidFill>
+                  <a:srgbClr val="C0392B"/>
+                </a:solidFill>
+                <a:latin typeface="Calibri"/>
+              </a:defRPr>
+            </a:pPr>
+            <a:r>
+              <a:t>Security Victory</a:t>
+            </a:r>
+          </a:p>
+        </p:txBody>
+      </p:sp>
+      <p:sp>
+        <p:nvSpPr>
+          <p:cNvPr id="5" name="TextBox 4"/>
+          <p:cNvSpPr txBox="1"/>
+          <p:nvPr/>
+        </p:nvSpPr>
+        <p:spPr>
+          <a:xfrm>
+            <a:off x="1097280" y="2103120"/>
+            <a:ext cx="4572000" cy="822960"/>
+          </a:xfrm>
+          <a:prstGeom prst="rect">
+            <a:avLst/>
+          </a:prstGeom>
+          <a:noFill/>
+        </p:spPr>
+        <p:txBody>
+          <a:bodyPr wrap="square">
+            <a:spAutoFit/>
+          </a:bodyPr>
+          <a:lstStyle/>
+          <a:p>
+            <a:pPr algn="l">
+              <a:defRPr sz="4800" b="1" i="0">
+                <a:solidFill>
+                  <a:srgbClr val="C0392B"/>
+                </a:solidFill>
+                <a:latin typeface="Calibri"/>
+              </a:defRPr>
+            </a:pPr>
+            <a:r>
+              <a:t>4</a:t>
+            </a:r>
+          </a:p>
+        </p:txBody>
+      </p:sp>
+      <p:sp>
+        <p:nvSpPr>
+          <p:cNvPr id="6" name="TextBox 5"/>
+          <p:cNvSpPr txBox="1"/>
+          <p:nvPr/>
+        </p:nvSpPr>
+        <p:spPr>
+          <a:xfrm>
+            <a:off x="1097280" y="2834640"/>
+            <a:ext cx="4572000" cy="365760"/>
+          </a:xfrm>
+          <a:prstGeom prst="rect">
+            <a:avLst/>
+          </a:prstGeom>
+          <a:noFill/>
+        </p:spPr>
+        <p:txBody>
+          <a:bodyPr wrap="square">
+            <a:spAutoFit/>
+          </a:bodyPr>
+          <a:lstStyle/>
+          <a:p>
+            <a:pPr algn="l">
+              <a:defRPr sz="1200" b="0" i="0">
+                <a:solidFill>
+                  <a:srgbClr val="8F95A3"/>
+                </a:solidFill>
+                <a:latin typeface="Calibri"/>
+              </a:defRPr>
+            </a:pPr>
+            <a:r>
+              <a:t>% fraud rate</a:t>
+            </a:r>
+          </a:p>
+        </p:txBody>
+      </p:sp>
+      <p:sp>
+        <p:nvSpPr>
+          <p:cNvPr id="7" name="TextBox 6"/>
+          <p:cNvSpPr txBox="1"/>
+          <p:nvPr/>
+        </p:nvSpPr>
+        <p:spPr>
+          <a:xfrm>
+            <a:off x="1097280" y="3291840"/>
+            <a:ext cx="9966960" cy="365760"/>
+          </a:xfrm>
+          <a:prstGeom prst="rect">
+            <a:avLst/>
+          </a:prstGeom>
+          <a:noFill/>
+        </p:spPr>
+        <p:txBody>
+          <a:bodyPr wrap="square">
+            <a:spAutoFit/>
+          </a:bodyPr>
+          <a:lstStyle/>
+          <a:p>
+            <a:pPr algn="l">
+              <a:defRPr sz="1400" b="0" i="0">
+                <a:solidFill>
+                  <a:srgbClr val="E2E2EA"/>
+                </a:solidFill>
+                <a:latin typeface="Calibri"/>
+              </a:defRPr>
+            </a:pPr>
+            <a:r>
+              <a:t>by Security Team</a:t>
+            </a:r>
+          </a:p>
+        </p:txBody>
+      </p:sp>
+      <p:sp>
+        <p:nvSpPr>
+          <p:cNvPr id="8" name="TextBox 7"/>
+          <p:cNvSpPr txBox="1"/>
+          <p:nvPr/>
+        </p:nvSpPr>
+        <p:spPr>
+          <a:xfrm>
+            <a:off x="1097280" y="3840480"/>
+            <a:ext cx="9966960" cy="457200"/>
+          </a:xfrm>
+          <a:prstGeom prst="rect">
+            <a:avLst/>
+          </a:prstGeom>
+          <a:noFill/>
+        </p:spPr>
+        <p:txBody>
+          <a:bodyPr wrap="square">
+            <a:spAutoFit/>
+          </a:bodyPr>
+          <a:lstStyle/>
+          <a:p>
+            <a:pPr algn="l">
+              <a:defRPr sz="1800" b="1" i="0">
+                <a:solidFill>
+                  <a:srgbClr val="FFFFFF"/>
+                </a:solidFill>
+                <a:latin typeface="Calibri"/>
+              </a:defRPr>
+            </a:pPr>
+            <a:r>
+              <a:t>Fraud Rate Dramatically Reduced</a:t>
+            </a:r>
+          </a:p>
+        </p:txBody>
+      </p:sp>
+      <p:sp>
+        <p:nvSpPr>
+          <p:cNvPr id="9" name="TextBox 8"/>
+          <p:cNvSpPr txBox="1"/>
+          <p:nvPr/>
+        </p:nvSpPr>
+        <p:spPr>
+          <a:xfrm>
+            <a:off x="1097280" y="4389120"/>
+            <a:ext cx="9966960" cy="914400"/>
+          </a:xfrm>
+          <a:prstGeom prst="rect">
+            <a:avLst/>
+          </a:prstGeom>
+          <a:noFill/>
+        </p:spPr>
+        <p:txBody>
+          <a:bodyPr wrap="square">
+            <a:spAutoFit/>
+          </a:bodyPr>
+          <a:lstStyle/>
+          <a:p>
+            <a:pPr algn="l">
+              <a:defRPr sz="1400" b="0" i="0">
+                <a:solidFill>
+                  <a:srgbClr val="E2E2EA"/>
+                </a:solidFill>
+                <a:latin typeface="Calibri"/>
+              </a:defRPr>
+            </a:pPr>
+            <a:r>
+              <a:t>Dynamic SDK signatures cut fraud from 22% to under 4%</a:t>
+            </a:r>
+          </a:p>
+        </p:txBody>
+      </p:sp>
+      <p:sp>
+        <p:nvSpPr>
+          <p:cNvPr id="10" name="TextBox 9"/>
+          <p:cNvSpPr txBox="1"/>
+          <p:nvPr/>
+        </p:nvSpPr>
+        <p:spPr>
+          <a:xfrm>
+            <a:off x="1097280" y="5486400"/>
+            <a:ext cx="9966960" cy="457200"/>
+          </a:xfrm>
+          <a:prstGeom prst="rect">
+            <a:avLst/>
+          </a:prstGeom>
+          <a:noFill/>
+        </p:spPr>
+        <p:txBody>
+          <a:bodyPr wrap="square">
+            <a:spAutoFit/>
+          </a:bodyPr>
+          <a:lstStyle/>
+          <a:p>
+            <a:pPr algn="l">
+              <a:defRPr sz="1300" b="0" i="1">
+                <a:solidFill>
+                  <a:srgbClr val="8F95A3"/>
+                </a:solidFill>
+                <a:latin typeface="Calibri"/>
+              </a:defRPr>
+            </a:pPr>
+            <a:r>
+              <a:t>💬 "Revolutionary security improvements protecting our ecosystem"</a:t>
+            </a:r>
+          </a:p>
+        </p:txBody>
+      </p:sp>
+    </p:spTree>
+  </p:cSld>
+  <p:clrMapOvr>
+    <a:masterClrMapping/>
+  </p:clrMapOvr>
+</p:sld>
+</file>
+
+<file path=ppt/slides/slide13.xml><?xml version="1.0" encoding="utf-8"?>
+<p:sld xmlns:a="http://schemas.openxmlformats.org/drawingml/2006/main" xmlns:p="http://schemas.openxmlformats.org/presentationml/2006/main" xmlns:r="http://schemas.openxmlformats.org/officeDocument/2006/relationships">
+  <p:cSld>
+    <p:bg>
+      <p:bgPr>
+        <a:solidFill>
+          <a:srgbClr val="08080C"/>
+        </a:solidFill>
+        <a:effectLst/>
+      </p:bgPr>
+    </p:bg>
+    <p:spTree>
+      <p:nvGrpSpPr>
+        <p:cNvPr id="1" name=""/>
+        <p:cNvGrpSpPr/>
+        <p:nvPr/>
+      </p:nvGrpSpPr>
+      <p:grpSpPr/>
+      <p:sp>
+        <p:nvSpPr>
+          <p:cNvPr id="2" name="Rectangle 1"/>
+          <p:cNvSpPr/>
+          <p:nvPr/>
+        </p:nvSpPr>
+        <p:spPr>
+          <a:xfrm>
+            <a:off x="0" y="365760"/>
+            <a:ext cx="12191695" cy="54864"/>
+          </a:xfrm>
+          <a:prstGeom prst="rect">
+            <a:avLst/>
+          </a:prstGeom>
+          <a:solidFill>
+            <a:srgbClr val="8E44AD"/>
+          </a:solidFill>
+          <a:ln>
+            <a:noFill/>
+          </a:ln>
+        </p:spPr>
+        <p:style>
+          <a:lnRef idx="1">
+            <a:schemeClr val="accent1"/>
+          </a:lnRef>
+          <a:fillRef idx="3">
+            <a:schemeClr val="accent1"/>
+          </a:fillRef>
+          <a:effectRef idx="2">
+            <a:schemeClr val="accent1"/>
+          </a:effectRef>
+          <a:fontRef idx="minor">
+            <a:schemeClr val="lt1"/>
+          </a:fontRef>
+        </p:style>
+        <p:txBody>
+          <a:bodyPr rtlCol="0" anchor="ctr"/>
+          <a:lstStyle/>
+          <a:p>
+            <a:pPr algn="ctr"/>
+          </a:p>
+        </p:txBody>
+      </p:sp>
+      <p:sp>
+        <p:nvSpPr>
+          <p:cNvPr id="3" name="TextBox 2"/>
+          <p:cNvSpPr txBox="1"/>
+          <p:nvPr/>
+        </p:nvSpPr>
+        <p:spPr>
+          <a:xfrm>
+            <a:off x="1097280" y="731520"/>
+            <a:ext cx="3657600" cy="365760"/>
+          </a:xfrm>
+          <a:prstGeom prst="rect">
+            <a:avLst/>
+          </a:prstGeom>
+          <a:noFill/>
+        </p:spPr>
+        <p:txBody>
+          <a:bodyPr wrap="none">
+            <a:spAutoFit/>
+          </a:bodyPr>
+          <a:lstStyle/>
+          <a:p>
+            <a:pPr algn="l">
+              <a:defRPr sz="1000" b="1">
+                <a:solidFill>
+                  <a:srgbClr val="8E44AD"/>
+                </a:solidFill>
+                <a:latin typeface="Calibri"/>
+              </a:defRPr>
+            </a:pPr>
+            <a:r>
+              <a:t>🎮  MILESTONE</a:t>
+            </a:r>
+          </a:p>
+        </p:txBody>
+      </p:sp>
+      <p:sp>
+        <p:nvSpPr>
+          <p:cNvPr id="4" name="TextBox 3"/>
+          <p:cNvSpPr txBox="1"/>
+          <p:nvPr/>
+        </p:nvSpPr>
+        <p:spPr>
+          <a:xfrm>
+            <a:off x="1097280" y="1188720"/>
+            <a:ext cx="9966960" cy="731520"/>
+          </a:xfrm>
+          <a:prstGeom prst="rect">
+            <a:avLst/>
+          </a:prstGeom>
+          <a:noFill/>
+        </p:spPr>
+        <p:txBody>
+          <a:bodyPr wrap="square">
+            <a:spAutoFit/>
+          </a:bodyPr>
+          <a:lstStyle/>
+          <a:p>
+            <a:pPr algn="l">
+              <a:defRPr sz="3200" b="1" i="0">
+                <a:solidFill>
+                  <a:srgbClr val="8E44AD"/>
+                </a:solidFill>
+                <a:latin typeface="Calibri"/>
+              </a:defRPr>
+            </a:pPr>
+            <a:r>
+              <a:t>Gaming Profitability</a:t>
+            </a:r>
+          </a:p>
+        </p:txBody>
+      </p:sp>
+      <p:sp>
+        <p:nvSpPr>
+          <p:cNvPr id="5" name="TextBox 4"/>
+          <p:cNvSpPr txBox="1"/>
+          <p:nvPr/>
+        </p:nvSpPr>
+        <p:spPr>
+          <a:xfrm>
+            <a:off x="1097280" y="2103120"/>
+            <a:ext cx="4572000" cy="822960"/>
+          </a:xfrm>
+          <a:prstGeom prst="rect">
+            <a:avLst/>
+          </a:prstGeom>
+          <a:noFill/>
+        </p:spPr>
+        <p:txBody>
+          <a:bodyPr wrap="square">
+            <a:spAutoFit/>
+          </a:bodyPr>
+          <a:lstStyle/>
+          <a:p>
+            <a:pPr algn="l">
+              <a:defRPr sz="5200" b="1" i="0">
+                <a:solidFill>
+                  <a:srgbClr val="8E44AD"/>
+                </a:solidFill>
+                <a:latin typeface="Calibri"/>
+              </a:defRPr>
+            </a:pPr>
+            <a:r>
+              <a:t>2025</a:t>
+            </a:r>
+          </a:p>
+        </p:txBody>
+      </p:sp>
+      <p:sp>
+        <p:nvSpPr>
+          <p:cNvPr id="6" name="TextBox 5"/>
+          <p:cNvSpPr txBox="1"/>
+          <p:nvPr/>
+        </p:nvSpPr>
+        <p:spPr>
+          <a:xfrm>
+            <a:off x="1097280" y="2926080"/>
+            <a:ext cx="4572000" cy="365760"/>
+          </a:xfrm>
+          <a:prstGeom prst="rect">
+            <a:avLst/>
+          </a:prstGeom>
+          <a:noFill/>
+        </p:spPr>
+        <p:txBody>
+          <a:bodyPr wrap="square">
+            <a:spAutoFit/>
+          </a:bodyPr>
+          <a:lstStyle/>
+          <a:p>
+            <a:pPr algn="l">
+              <a:defRPr sz="1100" b="0" i="0">
+                <a:solidFill>
+                  <a:srgbClr val="8F95A3"/>
+                </a:solidFill>
+                <a:latin typeface="Calibri"/>
+              </a:defRPr>
+            </a:pPr>
+            <a:r>
+              <a:t>Year Gaming Became Profitable</a:t>
+            </a:r>
+          </a:p>
+        </p:txBody>
+      </p:sp>
+      <p:sp>
+        <p:nvSpPr>
+          <p:cNvPr id="7" name="TextBox 6"/>
+          <p:cNvSpPr txBox="1"/>
+          <p:nvPr/>
+        </p:nvSpPr>
+        <p:spPr>
+          <a:xfrm>
+            <a:off x="1097280" y="3566160"/>
+            <a:ext cx="9966960" cy="457200"/>
+          </a:xfrm>
+          <a:prstGeom prst="rect">
+            <a:avLst/>
+          </a:prstGeom>
+          <a:noFill/>
+        </p:spPr>
+        <p:txBody>
+          <a:bodyPr wrap="square">
+            <a:spAutoFit/>
+          </a:bodyPr>
+          <a:lstStyle/>
+          <a:p>
+            <a:pPr algn="l">
+              <a:defRPr sz="1800" b="1" i="0">
+                <a:solidFill>
+                  <a:srgbClr val="FFFFFF"/>
+                </a:solidFill>
+                <a:latin typeface="Calibri"/>
+              </a:defRPr>
+            </a:pPr>
+            <a:r>
+              <a:t>Gaming Division Success</a:t>
+            </a:r>
+          </a:p>
+        </p:txBody>
+      </p:sp>
+      <p:sp>
+        <p:nvSpPr>
+          <p:cNvPr id="8" name="TextBox 7"/>
+          <p:cNvSpPr txBox="1"/>
+          <p:nvPr/>
+        </p:nvSpPr>
+        <p:spPr>
+          <a:xfrm>
+            <a:off x="1097280" y="4206240"/>
+            <a:ext cx="9966960" cy="1371600"/>
+          </a:xfrm>
+          <a:prstGeom prst="rect">
+            <a:avLst/>
+          </a:prstGeom>
+          <a:noFill/>
+        </p:spPr>
+        <p:txBody>
+          <a:bodyPr wrap="square">
+            <a:spAutoFit/>
+          </a:bodyPr>
+          <a:lstStyle/>
+          <a:p>
+            <a:pPr algn="l">
+              <a:defRPr sz="1500" b="0" i="0">
+                <a:solidFill>
+                  <a:srgbClr val="E2E2EA"/>
+                </a:solidFill>
+                <a:latin typeface="Calibri"/>
+              </a:defRPr>
+            </a:pPr>
+            <a:r>
+              <a:t>Strategic pivot delivers sustainable profitability</a:t>
+            </a:r>
+          </a:p>
+        </p:txBody>
+      </p:sp>
+    </p:spTree>
+  </p:cSld>
+  <p:clrMapOvr>
+    <a:masterClrMapping/>
+  </p:clrMapOvr>
+</p:sld>
+</file>
+
+<file path=ppt/slides/slide14.xml><?xml version="1.0" encoding="utf-8"?>
+<p:sld xmlns:a="http://schemas.openxmlformats.org/drawingml/2006/main" xmlns:p="http://schemas.openxmlformats.org/presentationml/2006/main" xmlns:r="http://schemas.openxmlformats.org/officeDocument/2006/relationships">
+  <p:cSld>
+    <p:bg>
+      <p:bgPr>
+        <a:solidFill>
+          <a:srgbClr val="08080C"/>
+        </a:solidFill>
+        <a:effectLst/>
+      </p:bgPr>
+    </p:bg>
+    <p:spTree>
+      <p:nvGrpSpPr>
+        <p:cNvPr id="1" name=""/>
+        <p:cNvGrpSpPr/>
+        <p:nvPr/>
+      </p:nvGrpSpPr>
+      <p:grpSpPr/>
+      <p:sp>
+        <p:nvSpPr>
+          <p:cNvPr id="2" name="Rectangle 1"/>
+          <p:cNvSpPr/>
+          <p:nvPr/>
+        </p:nvSpPr>
+        <p:spPr>
+          <a:xfrm>
+            <a:off x="0" y="365760"/>
+            <a:ext cx="12191695" cy="54864"/>
+          </a:xfrm>
+          <a:prstGeom prst="rect">
+            <a:avLst/>
+          </a:prstGeom>
+          <a:solidFill>
+            <a:srgbClr val="2ECC71"/>
+          </a:solidFill>
+          <a:ln>
+            <a:noFill/>
+          </a:ln>
+        </p:spPr>
+        <p:style>
+          <a:lnRef idx="1">
+            <a:schemeClr val="accent1"/>
+          </a:lnRef>
+          <a:fillRef idx="3">
+            <a:schemeClr val="accent1"/>
+          </a:fillRef>
+          <a:effectRef idx="2">
+            <a:schemeClr val="accent1"/>
+          </a:effectRef>
+          <a:fontRef idx="minor">
+            <a:schemeClr val="lt1"/>
+          </a:fontRef>
+        </p:style>
+        <p:txBody>
+          <a:bodyPr rtlCol="0" anchor="ctr"/>
+          <a:lstStyle/>
+          <a:p>
+            <a:pPr algn="ctr"/>
+          </a:p>
+        </p:txBody>
+      </p:sp>
+      <p:sp>
+        <p:nvSpPr>
+          <p:cNvPr id="3" name="TextBox 2"/>
+          <p:cNvSpPr txBox="1"/>
+          <p:nvPr/>
+        </p:nvSpPr>
+        <p:spPr>
+          <a:xfrm>
+            <a:off x="1097280" y="731520"/>
+            <a:ext cx="3657600" cy="365760"/>
+          </a:xfrm>
+          <a:prstGeom prst="rect">
+            <a:avLst/>
+          </a:prstGeom>
+          <a:noFill/>
+        </p:spPr>
+        <p:txBody>
+          <a:bodyPr wrap="none">
+            <a:spAutoFit/>
+          </a:bodyPr>
+          <a:lstStyle/>
+          <a:p>
+            <a:pPr algn="l">
+              <a:defRPr sz="1000" b="1">
+                <a:solidFill>
+                  <a:srgbClr val="2ECC71"/>
+                </a:solidFill>
+                <a:latin typeface="Calibri"/>
+              </a:defRPr>
+            </a:pPr>
+            <a:r>
+              <a:t>🎯  WIN</a:t>
+            </a:r>
+          </a:p>
+        </p:txBody>
+      </p:sp>
+      <p:sp>
+        <p:nvSpPr>
+          <p:cNvPr id="4" name="TextBox 3"/>
+          <p:cNvSpPr txBox="1"/>
+          <p:nvPr/>
+        </p:nvSpPr>
+        <p:spPr>
+          <a:xfrm>
+            <a:off x="1097280" y="1188720"/>
+            <a:ext cx="9966960" cy="731520"/>
+          </a:xfrm>
+          <a:prstGeom prst="rect">
+            <a:avLst/>
+          </a:prstGeom>
+          <a:noFill/>
+        </p:spPr>
+        <p:txBody>
+          <a:bodyPr wrap="square">
+            <a:spAutoFit/>
+          </a:bodyPr>
+          <a:lstStyle/>
+          <a:p>
+            <a:pPr algn="l">
+              <a:defRPr sz="3200" b="1" i="0">
+                <a:solidFill>
+                  <a:srgbClr val="2ECC71"/>
+                </a:solidFill>
+                <a:latin typeface="Calibri"/>
+              </a:defRPr>
+            </a:pPr>
+            <a:r>
+              <a:t>Retention Excellence</a:t>
+            </a:r>
+          </a:p>
+        </p:txBody>
+      </p:sp>
+      <p:sp>
+        <p:nvSpPr>
+          <p:cNvPr id="5" name="TextBox 4"/>
+          <p:cNvSpPr txBox="1"/>
+          <p:nvPr/>
+        </p:nvSpPr>
+        <p:spPr>
+          <a:xfrm>
+            <a:off x="1097280" y="2103120"/>
+            <a:ext cx="4572000" cy="822960"/>
+          </a:xfrm>
+          <a:prstGeom prst="rect">
+            <a:avLst/>
+          </a:prstGeom>
+          <a:noFill/>
+        </p:spPr>
+        <p:txBody>
+          <a:bodyPr wrap="square">
+            <a:spAutoFit/>
+          </a:bodyPr>
+          <a:lstStyle/>
+          <a:p>
+            <a:pPr algn="l">
+              <a:defRPr sz="4800" b="1" i="0">
+                <a:solidFill>
+                  <a:srgbClr val="2ECC71"/>
+                </a:solidFill>
+                <a:latin typeface="Calibri"/>
+              </a:defRPr>
+            </a:pPr>
+            <a:r>
+              <a:t>61</a:t>
+            </a:r>
+          </a:p>
+        </p:txBody>
+      </p:sp>
+      <p:sp>
+        <p:nvSpPr>
+          <p:cNvPr id="6" name="TextBox 5"/>
+          <p:cNvSpPr txBox="1"/>
+          <p:nvPr/>
+        </p:nvSpPr>
+        <p:spPr>
+          <a:xfrm>
+            <a:off x="1097280" y="2834640"/>
+            <a:ext cx="4572000" cy="365760"/>
+          </a:xfrm>
+          <a:prstGeom prst="rect">
+            <a:avLst/>
+          </a:prstGeom>
+          <a:noFill/>
+        </p:spPr>
+        <p:txBody>
+          <a:bodyPr wrap="square">
+            <a:spAutoFit/>
+          </a:bodyPr>
+          <a:lstStyle/>
+          <a:p>
+            <a:pPr algn="l">
+              <a:defRPr sz="1200" b="0" i="0">
+                <a:solidFill>
+                  <a:srgbClr val="8F95A3"/>
+                </a:solidFill>
+                <a:latin typeface="Calibri"/>
+              </a:defRPr>
+            </a:pPr>
+            <a:r>
+              <a:t>% retention</a:t>
+            </a:r>
+          </a:p>
+        </p:txBody>
+      </p:sp>
+      <p:sp>
+        <p:nvSpPr>
+          <p:cNvPr id="7" name="TextBox 6"/>
+          <p:cNvSpPr txBox="1"/>
+          <p:nvPr/>
+        </p:nvSpPr>
+        <p:spPr>
+          <a:xfrm>
+            <a:off x="1097280" y="3291840"/>
+            <a:ext cx="9966960" cy="365760"/>
+          </a:xfrm>
+          <a:prstGeom prst="rect">
+            <a:avLst/>
+          </a:prstGeom>
+          <a:noFill/>
+        </p:spPr>
+        <p:txBody>
+          <a:bodyPr wrap="square">
+            <a:spAutoFit/>
+          </a:bodyPr>
+          <a:lstStyle/>
+          <a:p>
+            <a:pPr algn="l">
+              <a:defRPr sz="1400" b="0" i="0">
+                <a:solidFill>
+                  <a:srgbClr val="E2E2EA"/>
+                </a:solidFill>
+                <a:latin typeface="Calibri"/>
+              </a:defRPr>
+            </a:pPr>
+            <a:r>
+              <a:t>by Game Development Team</a:t>
+            </a:r>
+          </a:p>
+        </p:txBody>
+      </p:sp>
+      <p:sp>
+        <p:nvSpPr>
+          <p:cNvPr id="8" name="TextBox 7"/>
+          <p:cNvSpPr txBox="1"/>
+          <p:nvPr/>
+        </p:nvSpPr>
+        <p:spPr>
+          <a:xfrm>
+            <a:off x="1097280" y="3840480"/>
+            <a:ext cx="9966960" cy="457200"/>
+          </a:xfrm>
+          <a:prstGeom prst="rect">
+            <a:avLst/>
+          </a:prstGeom>
+          <a:noFill/>
+        </p:spPr>
+        <p:txBody>
+          <a:bodyPr wrap="square">
+            <a:spAutoFit/>
+          </a:bodyPr>
+          <a:lstStyle/>
+          <a:p>
+            <a:pPr algn="l">
+              <a:defRPr sz="1800" b="1" i="0">
+                <a:solidFill>
+                  <a:srgbClr val="FFFFFF"/>
+                </a:solidFill>
+                <a:latin typeface="Calibri"/>
+              </a:defRPr>
+            </a:pPr>
+            <a:r>
+              <a:t>Infinite Minesweeper Crushing Benchmarks</a:t>
+            </a:r>
+          </a:p>
+        </p:txBody>
+      </p:sp>
+      <p:sp>
+        <p:nvSpPr>
+          <p:cNvPr id="9" name="TextBox 8"/>
+          <p:cNvSpPr txBox="1"/>
+          <p:nvPr/>
+        </p:nvSpPr>
+        <p:spPr>
+          <a:xfrm>
+            <a:off x="1097280" y="4389120"/>
+            <a:ext cx="9966960" cy="914400"/>
+          </a:xfrm>
+          <a:prstGeom prst="rect">
+            <a:avLst/>
+          </a:prstGeom>
+          <a:noFill/>
+        </p:spPr>
+        <p:txBody>
+          <a:bodyPr wrap="square">
+            <a:spAutoFit/>
+          </a:bodyPr>
+          <a:lstStyle/>
+          <a:p>
+            <a:pPr algn="l">
+              <a:defRPr sz="1400" b="0" i="0">
+                <a:solidFill>
+                  <a:srgbClr val="E2E2EA"/>
+                </a:solidFill>
+                <a:latin typeface="Calibri"/>
+              </a:defRPr>
+            </a:pPr>
+            <a:r>
+              <a:t>Exceeding Apple benchmark retention rates consistently</a:t>
+            </a:r>
+          </a:p>
+        </p:txBody>
+      </p:sp>
+      <p:sp>
+        <p:nvSpPr>
+          <p:cNvPr id="10" name="TextBox 9"/>
+          <p:cNvSpPr txBox="1"/>
+          <p:nvPr/>
+        </p:nvSpPr>
+        <p:spPr>
+          <a:xfrm>
+            <a:off x="1097280" y="5486400"/>
+            <a:ext cx="9966960" cy="457200"/>
+          </a:xfrm>
+          <a:prstGeom prst="rect">
+            <a:avLst/>
+          </a:prstGeom>
+          <a:noFill/>
+        </p:spPr>
+        <p:txBody>
+          <a:bodyPr wrap="square">
+            <a:spAutoFit/>
+          </a:bodyPr>
+          <a:lstStyle/>
+          <a:p>
+            <a:pPr algn="l">
+              <a:defRPr sz="1300" b="0" i="1">
+                <a:solidFill>
+                  <a:srgbClr val="8F95A3"/>
+                </a:solidFill>
+                <a:latin typeface="Calibri"/>
+              </a:defRPr>
+            </a:pPr>
+            <a:r>
+              <a:t>💬 "Player engagement strategies delivering exceptional results"</a:t>
+            </a:r>
+          </a:p>
+        </p:txBody>
+      </p:sp>
+    </p:spTree>
+  </p:cSld>
+  <p:clrMapOvr>
+    <a:masterClrMapping/>
+  </p:clrMapOvr>
+</p:sld>
+</file>
+
+<file path=ppt/slides/slide15.xml><?xml version="1.0" encoding="utf-8"?>
+<p:sld xmlns:a="http://schemas.openxmlformats.org/drawingml/2006/main" xmlns:p="http://schemas.openxmlformats.org/presentationml/2006/main" xmlns:r="http://schemas.openxmlformats.org/officeDocument/2006/relationships">
+  <p:cSld>
+    <p:bg>
+      <p:bgPr>
+        <a:solidFill>
+          <a:srgbClr val="08080C"/>
+        </a:solidFill>
+        <a:effectLst/>
+      </p:bgPr>
+    </p:bg>
+    <p:spTree>
+      <p:nvGrpSpPr>
+        <p:cNvPr id="1" name=""/>
+        <p:cNvGrpSpPr/>
+        <p:nvPr/>
+      </p:nvGrpSpPr>
+      <p:grpSpPr/>
+      <p:sp>
+        <p:nvSpPr>
+          <p:cNvPr id="2" name="Rectangle 1"/>
+          <p:cNvSpPr/>
+          <p:nvPr/>
+        </p:nvSpPr>
+        <p:spPr>
+          <a:xfrm>
+            <a:off x="0" y="365760"/>
+            <a:ext cx="12191695" cy="54864"/>
+          </a:xfrm>
+          <a:prstGeom prst="rect">
+            <a:avLst/>
+          </a:prstGeom>
+          <a:solidFill>
+            <a:srgbClr val="3498DB"/>
+          </a:solidFill>
+          <a:ln>
+            <a:noFill/>
+          </a:ln>
+        </p:spPr>
+        <p:style>
+          <a:lnRef idx="1">
+            <a:schemeClr val="accent1"/>
+          </a:lnRef>
+          <a:fillRef idx="3">
+            <a:schemeClr val="accent1"/>
+          </a:fillRef>
+          <a:effectRef idx="2">
+            <a:schemeClr val="accent1"/>
+          </a:effectRef>
+          <a:fontRef idx="minor">
+            <a:schemeClr val="lt1"/>
+          </a:fontRef>
+        </p:style>
+        <p:txBody>
+          <a:bodyPr rtlCol="0" anchor="ctr"/>
+          <a:lstStyle/>
+          <a:p>
+            <a:pPr algn="ctr"/>
+          </a:p>
+        </p:txBody>
+      </p:sp>
+      <p:sp>
+        <p:nvSpPr>
+          <p:cNvPr id="3" name="TextBox 2"/>
+          <p:cNvSpPr txBox="1"/>
+          <p:nvPr/>
+        </p:nvSpPr>
+        <p:spPr>
+          <a:xfrm>
+            <a:off x="1097280" y="731520"/>
+            <a:ext cx="3657600" cy="365760"/>
+          </a:xfrm>
+          <a:prstGeom prst="rect">
+            <a:avLst/>
+          </a:prstGeom>
+          <a:noFill/>
+        </p:spPr>
+        <p:txBody>
+          <a:bodyPr wrap="none">
+            <a:spAutoFit/>
+          </a:bodyPr>
+          <a:lstStyle/>
+          <a:p>
+            <a:pPr algn="l">
+              <a:defRPr sz="1000" b="1">
+                <a:solidFill>
+                  <a:srgbClr val="3498DB"/>
+                </a:solidFill>
+                <a:latin typeface="Calibri"/>
+              </a:defRPr>
+            </a:pPr>
+            <a:r>
+              <a:t>🤖  WIN</a:t>
+            </a:r>
+          </a:p>
+        </p:txBody>
+      </p:sp>
+      <p:sp>
+        <p:nvSpPr>
+          <p:cNvPr id="4" name="TextBox 3"/>
+          <p:cNvSpPr txBox="1"/>
+          <p:nvPr/>
+        </p:nvSpPr>
+        <p:spPr>
+          <a:xfrm>
+            <a:off x="1097280" y="1188720"/>
+            <a:ext cx="9966960" cy="731520"/>
+          </a:xfrm>
+          <a:prstGeom prst="rect">
+            <a:avLst/>
+          </a:prstGeom>
+          <a:noFill/>
+        </p:spPr>
+        <p:txBody>
+          <a:bodyPr wrap="square">
+            <a:spAutoFit/>
+          </a:bodyPr>
+          <a:lstStyle/>
+          <a:p>
+            <a:pPr algn="l">
+              <a:defRPr sz="3200" b="1" i="0">
+                <a:solidFill>
+                  <a:srgbClr val="3498DB"/>
+                </a:solidFill>
+                <a:latin typeface="Calibri"/>
+              </a:defRPr>
+            </a:pPr>
+            <a:r>
+              <a:t>AI Automation Win</a:t>
+            </a:r>
+          </a:p>
+        </p:txBody>
+      </p:sp>
+      <p:sp>
+        <p:nvSpPr>
+          <p:cNvPr id="5" name="TextBox 4"/>
+          <p:cNvSpPr txBox="1"/>
+          <p:nvPr/>
+        </p:nvSpPr>
+        <p:spPr>
+          <a:xfrm>
+            <a:off x="1097280" y="2103120"/>
+            <a:ext cx="4572000" cy="822960"/>
+          </a:xfrm>
+          <a:prstGeom prst="rect">
+            <a:avLst/>
+          </a:prstGeom>
+          <a:noFill/>
+        </p:spPr>
+        <p:txBody>
+          <a:bodyPr wrap="square">
+            <a:spAutoFit/>
+          </a:bodyPr>
+          <a:lstStyle/>
+          <a:p>
+            <a:pPr algn="l">
+              <a:defRPr sz="4800" b="1" i="0">
+                <a:solidFill>
+                  <a:srgbClr val="3498DB"/>
+                </a:solidFill>
+                <a:latin typeface="Calibri"/>
+              </a:defRPr>
+            </a:pPr>
+            <a:r>
+              <a:t>$4k</a:t>
+            </a:r>
+          </a:p>
+        </p:txBody>
+      </p:sp>
+      <p:sp>
+        <p:nvSpPr>
+          <p:cNvPr id="6" name="TextBox 5"/>
+          <p:cNvSpPr txBox="1"/>
+          <p:nvPr/>
+        </p:nvSpPr>
+        <p:spPr>
+          <a:xfrm>
+            <a:off x="1097280" y="2834640"/>
+            <a:ext cx="4572000" cy="365760"/>
+          </a:xfrm>
+          <a:prstGeom prst="rect">
+            <a:avLst/>
+          </a:prstGeom>
+          <a:noFill/>
+        </p:spPr>
+        <p:txBody>
+          <a:bodyPr wrap="square">
+            <a:spAutoFit/>
+          </a:bodyPr>
+          <a:lstStyle/>
+          <a:p>
+            <a:pPr algn="l">
+              <a:defRPr sz="1200" b="0" i="0">
+                <a:solidFill>
+                  <a:srgbClr val="8F95A3"/>
+                </a:solidFill>
+                <a:latin typeface="Calibri"/>
+              </a:defRPr>
+            </a:pPr>
+            <a:r>
+              <a:t>saved per week</a:t>
+            </a:r>
+          </a:p>
+        </p:txBody>
+      </p:sp>
+      <p:sp>
+        <p:nvSpPr>
+          <p:cNvPr id="7" name="TextBox 6"/>
+          <p:cNvSpPr txBox="1"/>
+          <p:nvPr/>
+        </p:nvSpPr>
+        <p:spPr>
+          <a:xfrm>
+            <a:off x="1097280" y="3291840"/>
+            <a:ext cx="9966960" cy="365760"/>
+          </a:xfrm>
+          <a:prstGeom prst="rect">
+            <a:avLst/>
+          </a:prstGeom>
+          <a:noFill/>
+        </p:spPr>
+        <p:txBody>
+          <a:bodyPr wrap="square">
+            <a:spAutoFit/>
+          </a:bodyPr>
+          <a:lstStyle/>
+          <a:p>
+            <a:pPr algn="l">
+              <a:defRPr sz="1400" b="0" i="0">
+                <a:solidFill>
+                  <a:srgbClr val="E2E2EA"/>
+                </a:solidFill>
+                <a:latin typeface="Calibri"/>
+              </a:defRPr>
+            </a:pPr>
+            <a:r>
+              <a:t>by AI Development Team</a:t>
+            </a:r>
+          </a:p>
+        </p:txBody>
+      </p:sp>
+      <p:sp>
+        <p:nvSpPr>
+          <p:cNvPr id="8" name="TextBox 7"/>
+          <p:cNvSpPr txBox="1"/>
+          <p:nvPr/>
+        </p:nvSpPr>
+        <p:spPr>
+          <a:xfrm>
+            <a:off x="1097280" y="3840480"/>
+            <a:ext cx="9966960" cy="457200"/>
+          </a:xfrm>
+          <a:prstGeom prst="rect">
+            <a:avLst/>
+          </a:prstGeom>
+          <a:noFill/>
+        </p:spPr>
+        <p:txBody>
+          <a:bodyPr wrap="square">
+            <a:spAutoFit/>
+          </a:bodyPr>
+          <a:lstStyle/>
+          <a:p>
+            <a:pPr algn="l">
+              <a:defRPr sz="1800" b="1" i="0">
+                <a:solidFill>
+                  <a:srgbClr val="FFFFFF"/>
+                </a:solidFill>
+                <a:latin typeface="Calibri"/>
+              </a:defRPr>
+            </a:pPr>
+            <a:r>
+              <a:t>Daria AI Bot Delivering ROI</a:t>
+            </a:r>
+          </a:p>
+        </p:txBody>
+      </p:sp>
+      <p:sp>
+        <p:nvSpPr>
+          <p:cNvPr id="9" name="TextBox 8"/>
+          <p:cNvSpPr txBox="1"/>
+          <p:nvPr/>
+        </p:nvSpPr>
+        <p:spPr>
+          <a:xfrm>
+            <a:off x="1097280" y="4389120"/>
+            <a:ext cx="9966960" cy="914400"/>
+          </a:xfrm>
+          <a:prstGeom prst="rect">
+            <a:avLst/>
+          </a:prstGeom>
+          <a:noFill/>
+        </p:spPr>
+        <p:txBody>
+          <a:bodyPr wrap="square">
+            <a:spAutoFit/>
+          </a:bodyPr>
+          <a:lstStyle/>
+          <a:p>
+            <a:pPr algn="l">
+              <a:defRPr sz="1400" b="0" i="0">
+                <a:solidFill>
+                  <a:srgbClr val="E2E2EA"/>
+                </a:solidFill>
+                <a:latin typeface="Calibri"/>
+              </a:defRPr>
+            </a:pPr>
+            <a:r>
+              <a:t>Automated app review analysis saving significant resources</a:t>
+            </a:r>
+          </a:p>
+        </p:txBody>
+      </p:sp>
+      <p:sp>
+        <p:nvSpPr>
+          <p:cNvPr id="10" name="TextBox 9"/>
+          <p:cNvSpPr txBox="1"/>
+          <p:nvPr/>
+        </p:nvSpPr>
+        <p:spPr>
+          <a:xfrm>
+            <a:off x="1097280" y="5486400"/>
+            <a:ext cx="9966960" cy="457200"/>
+          </a:xfrm>
+          <a:prstGeom prst="rect">
+            <a:avLst/>
+          </a:prstGeom>
+          <a:noFill/>
+        </p:spPr>
+        <p:txBody>
+          <a:bodyPr wrap="square">
+            <a:spAutoFit/>
+          </a:bodyPr>
+          <a:lstStyle/>
+          <a:p>
+            <a:pPr algn="l">
+              <a:defRPr sz="1300" b="0" i="1">
+                <a:solidFill>
+                  <a:srgbClr val="8F95A3"/>
+                </a:solidFill>
+                <a:latin typeface="Calibri"/>
+              </a:defRPr>
+            </a:pPr>
+            <a:r>
+              <a:t>💬 "AI-first approach generating measurable business value"</a:t>
+            </a:r>
+          </a:p>
+        </p:txBody>
+      </p:sp>
+    </p:spTree>
+  </p:cSld>
+  <p:clrMapOvr>
+    <a:masterClrMapping/>
+  </p:clrMapOvr>
+</p:sld>
+</file>
+
+<file path=ppt/slides/slide16.xml><?xml version="1.0" encoding="utf-8"?>
+<p:sld xmlns:a="http://schemas.openxmlformats.org/drawingml/2006/main" xmlns:p="http://schemas.openxmlformats.org/presentationml/2006/main" xmlns:r="http://schemas.openxmlformats.org/officeDocument/2006/relationships">
+  <p:cSld>
+    <p:bg>
+      <p:bgPr>
+        <a:solidFill>
+          <a:srgbClr val="08080C"/>
+        </a:solidFill>
+        <a:effectLst/>
+      </p:bgPr>
+    </p:bg>
+    <p:spTree>
+      <p:nvGrpSpPr>
+        <p:cNvPr id="1" name=""/>
+        <p:cNvGrpSpPr/>
+        <p:nvPr/>
+      </p:nvGrpSpPr>
+      <p:grpSpPr/>
+      <p:sp>
+        <p:nvSpPr>
+          <p:cNvPr id="2" name="Rectangle 1"/>
+          <p:cNvSpPr/>
+          <p:nvPr/>
+        </p:nvSpPr>
+        <p:spPr>
+          <a:xfrm>
+            <a:off x="0" y="365760"/>
+            <a:ext cx="12191695" cy="54864"/>
+          </a:xfrm>
+          <a:prstGeom prst="rect">
+            <a:avLst/>
+          </a:prstGeom>
+          <a:solidFill>
+            <a:srgbClr val="F1C40F"/>
+          </a:solidFill>
+          <a:ln>
+            <a:noFill/>
+          </a:ln>
+        </p:spPr>
+        <p:style>
+          <a:lnRef idx="1">
+            <a:schemeClr val="accent1"/>
+          </a:lnRef>
+          <a:fillRef idx="3">
+            <a:schemeClr val="accent1"/>
+          </a:fillRef>
+          <a:effectRef idx="2">
+            <a:schemeClr val="accent1"/>
+          </a:effectRef>
+          <a:fontRef idx="minor">
+            <a:schemeClr val="lt1"/>
+          </a:fontRef>
+        </p:style>
+        <p:txBody>
+          <a:bodyPr rtlCol="0" anchor="ctr"/>
+          <a:lstStyle/>
+          <a:p>
+            <a:pPr algn="ctr"/>
+          </a:p>
+        </p:txBody>
+      </p:sp>
+      <p:sp>
+        <p:nvSpPr>
+          <p:cNvPr id="3" name="TextBox 2"/>
+          <p:cNvSpPr txBox="1"/>
+          <p:nvPr/>
+        </p:nvSpPr>
+        <p:spPr>
+          <a:xfrm>
+            <a:off x="1097280" y="731520"/>
+            <a:ext cx="3657600" cy="365760"/>
+          </a:xfrm>
+          <a:prstGeom prst="rect">
+            <a:avLst/>
+          </a:prstGeom>
+          <a:noFill/>
+        </p:spPr>
+        <p:txBody>
+          <a:bodyPr wrap="none">
+            <a:spAutoFit/>
+          </a:bodyPr>
+          <a:lstStyle/>
+          <a:p>
+            <a:pPr algn="l">
+              <a:defRPr sz="1000" b="1">
+                <a:solidFill>
+                  <a:srgbClr val="F1C40F"/>
+                </a:solidFill>
+                <a:latin typeface="Calibri"/>
+              </a:defRPr>
+            </a:pPr>
+            <a:r>
+              <a:t>🏆  CLAPS</a:t>
+            </a:r>
+          </a:p>
+        </p:txBody>
+      </p:sp>
+      <p:sp>
+        <p:nvSpPr>
+          <p:cNvPr id="4" name="TextBox 3"/>
+          <p:cNvSpPr txBox="1"/>
+          <p:nvPr/>
+        </p:nvSpPr>
+        <p:spPr>
+          <a:xfrm>
+            <a:off x="1097280" y="1188720"/>
+            <a:ext cx="9966960" cy="731520"/>
+          </a:xfrm>
+          <a:prstGeom prst="rect">
+            <a:avLst/>
+          </a:prstGeom>
+          <a:noFill/>
+        </p:spPr>
+        <p:txBody>
+          <a:bodyPr wrap="square">
+            <a:spAutoFit/>
+          </a:bodyPr>
+          <a:lstStyle/>
+          <a:p>
+            <a:pPr algn="l">
+              <a:defRPr sz="3200" b="1" i="0">
+                <a:solidFill>
+                  <a:srgbClr val="F1C40F"/>
+                </a:solidFill>
+                <a:latin typeface="Calibri"/>
+              </a:defRPr>
+            </a:pPr>
+            <a:r>
+              <a:t>Marketing Excellence</a:t>
+            </a:r>
+          </a:p>
+        </p:txBody>
+      </p:sp>
+      <p:sp>
+        <p:nvSpPr>
+          <p:cNvPr id="5" name="TextBox 4"/>
+          <p:cNvSpPr txBox="1"/>
+          <p:nvPr/>
+        </p:nvSpPr>
+        <p:spPr>
+          <a:xfrm>
+            <a:off x="1097280" y="2103120"/>
+            <a:ext cx="2743200" cy="548640"/>
+          </a:xfrm>
+          <a:prstGeom prst="rect">
+            <a:avLst/>
+          </a:prstGeom>
+          <a:noFill/>
+        </p:spPr>
+        <p:txBody>
+          <a:bodyPr wrap="square">
+            <a:spAutoFit/>
+          </a:bodyPr>
+          <a:lstStyle/>
+          <a:p>
+            <a:pPr algn="l">
+              <a:defRPr sz="2800" b="1" i="0">
+                <a:solidFill>
+                  <a:srgbClr val="F1C40F"/>
+                </a:solidFill>
+                <a:latin typeface="Calibri"/>
+              </a:defRPr>
+            </a:pPr>
+            <a:r>
+              <a:t>30</a:t>
+            </a:r>
+          </a:p>
+        </p:txBody>
+      </p:sp>
+      <p:sp>
+        <p:nvSpPr>
+          <p:cNvPr id="6" name="TextBox 5"/>
+          <p:cNvSpPr txBox="1"/>
+          <p:nvPr/>
+        </p:nvSpPr>
+        <p:spPr>
+          <a:xfrm>
+            <a:off x="1097280" y="2651760"/>
+            <a:ext cx="9966960" cy="365760"/>
+          </a:xfrm>
+          <a:prstGeom prst="rect">
+            <a:avLst/>
+          </a:prstGeom>
+          <a:noFill/>
+        </p:spPr>
+        <p:txBody>
+          <a:bodyPr wrap="square">
+            <a:spAutoFit/>
+          </a:bodyPr>
+          <a:lstStyle/>
+          <a:p>
+            <a:pPr algn="l">
+              <a:defRPr sz="1400" b="0" i="0">
+                <a:solidFill>
+                  <a:srgbClr val="E2E2EA"/>
+                </a:solidFill>
+                <a:latin typeface="Calibri"/>
+              </a:defRPr>
+            </a:pPr>
+            <a:r>
+              <a:t>from Gleb Krahotkin</a:t>
+            </a:r>
+          </a:p>
+        </p:txBody>
+      </p:sp>
+      <p:sp>
+        <p:nvSpPr>
+          <p:cNvPr id="7" name="TextBox 6"/>
+          <p:cNvSpPr txBox="1"/>
+          <p:nvPr/>
+        </p:nvSpPr>
+        <p:spPr>
+          <a:xfrm>
+            <a:off x="1097280" y="3108960"/>
+            <a:ext cx="9966960" cy="365760"/>
+          </a:xfrm>
+          <a:prstGeom prst="rect">
+            <a:avLst/>
+          </a:prstGeom>
+          <a:noFill/>
+        </p:spPr>
+        <p:txBody>
+          <a:bodyPr wrap="square">
+            <a:spAutoFit/>
+          </a:bodyPr>
+          <a:lstStyle/>
+          <a:p>
+            <a:pPr algn="l">
+              <a:defRPr sz="1400" b="1" i="0">
+                <a:solidFill>
+                  <a:srgbClr val="FFFFFF"/>
+                </a:solidFill>
+                <a:latin typeface="Calibri"/>
+              </a:defRPr>
+            </a:pPr>
+            <a:r>
+              <a:t>to: Hierman Pelekh</a:t>
+            </a:r>
+          </a:p>
+        </p:txBody>
+      </p:sp>
+      <p:sp>
+        <p:nvSpPr>
+          <p:cNvPr id="8" name="TextBox 7"/>
+          <p:cNvSpPr txBox="1"/>
+          <p:nvPr/>
+        </p:nvSpPr>
+        <p:spPr>
+          <a:xfrm>
+            <a:off x="1097280" y="3749039"/>
+            <a:ext cx="9966960" cy="1097280"/>
+          </a:xfrm>
+          <a:prstGeom prst="rect">
+            <a:avLst/>
+          </a:prstGeom>
+          <a:noFill/>
+        </p:spPr>
+        <p:txBody>
+          <a:bodyPr wrap="square">
+            <a:spAutoFit/>
+          </a:bodyPr>
+          <a:lstStyle/>
+          <a:p>
+            <a:pPr algn="l">
+              <a:defRPr sz="1500" b="0" i="1">
+                <a:solidFill>
+                  <a:srgbClr val="E2E2EA"/>
+                </a:solidFill>
+                <a:latin typeface="Calibri"/>
+              </a:defRPr>
+            </a:pPr>
+            <a:r>
+              <a:t>"Outstanding marketing campaign performance"</a:t>
+            </a:r>
+          </a:p>
+        </p:txBody>
+      </p:sp>
+      <p:sp>
+        <p:nvSpPr>
+          <p:cNvPr id="9" name="TextBox 8"/>
+          <p:cNvSpPr txBox="1"/>
+          <p:nvPr/>
+        </p:nvSpPr>
+        <p:spPr>
+          <a:xfrm>
+            <a:off x="1097280" y="5120640"/>
+            <a:ext cx="9966960" cy="457200"/>
+          </a:xfrm>
+          <a:prstGeom prst="rect">
+            <a:avLst/>
+          </a:prstGeom>
+          <a:noFill/>
+        </p:spPr>
+        <p:txBody>
+          <a:bodyPr wrap="square">
+            <a:spAutoFit/>
+          </a:bodyPr>
+          <a:lstStyle/>
+          <a:p>
+            <a:pPr algn="l">
+              <a:defRPr sz="1200" b="1" i="0">
+                <a:solidFill>
+                  <a:srgbClr val="F1C40F"/>
+                </a:solidFill>
+                <a:latin typeface="Calibri"/>
+              </a:defRPr>
+            </a:pPr>
+            <a:r>
+              <a:t>EXCELLENCE · INNOVATION</a:t>
+            </a:r>
+          </a:p>
+        </p:txBody>
+      </p:sp>
+    </p:spTree>
+  </p:cSld>
+  <p:clrMapOvr>
+    <a:masterClrMapping/>
+  </p:clrMapOvr>
+</p:sld>
+</file>
+
+<file path=ppt/slides/slide17.xml><?xml version="1.0" encoding="utf-8"?>
+<p:sld xmlns:a="http://schemas.openxmlformats.org/drawingml/2006/main" xmlns:p="http://schemas.openxmlformats.org/presentationml/2006/main" xmlns:r="http://schemas.openxmlformats.org/officeDocument/2006/relationships">
+  <p:cSld>
+    <p:bg>
+      <p:bgPr>
+        <a:solidFill>
+          <a:srgbClr val="08080C"/>
+        </a:solidFill>
+        <a:effectLst/>
+      </p:bgPr>
+    </p:bg>
+    <p:spTree>
+      <p:nvGrpSpPr>
+        <p:cNvPr id="1" name=""/>
+        <p:cNvGrpSpPr/>
+        <p:nvPr/>
+      </p:nvGrpSpPr>
+      <p:grpSpPr/>
+      <p:sp>
+        <p:nvSpPr>
+          <p:cNvPr id="2" name="Rectangle 1"/>
+          <p:cNvSpPr/>
+          <p:nvPr/>
+        </p:nvSpPr>
+        <p:spPr>
+          <a:xfrm>
+            <a:off x="0" y="365760"/>
+            <a:ext cx="12191695" cy="54864"/>
+          </a:xfrm>
+          <a:prstGeom prst="rect">
+            <a:avLst/>
+          </a:prstGeom>
+          <a:solidFill>
+            <a:srgbClr val="34495E"/>
+          </a:solidFill>
+          <a:ln>
+            <a:noFill/>
+          </a:ln>
+        </p:spPr>
+        <p:style>
+          <a:lnRef idx="1">
+            <a:schemeClr val="accent1"/>
+          </a:lnRef>
+          <a:fillRef idx="3">
+            <a:schemeClr val="accent1"/>
+          </a:fillRef>
+          <a:effectRef idx="2">
+            <a:schemeClr val="accent1"/>
+          </a:effectRef>
+          <a:fontRef idx="minor">
+            <a:schemeClr val="lt1"/>
+          </a:fontRef>
+        </p:style>
+        <p:txBody>
+          <a:bodyPr rtlCol="0" anchor="ctr"/>
+          <a:lstStyle/>
+          <a:p>
+            <a:pPr algn="ctr"/>
+          </a:p>
+        </p:txBody>
+      </p:sp>
+      <p:sp>
+        <p:nvSpPr>
+          <p:cNvPr id="3" name="TextBox 2"/>
+          <p:cNvSpPr txBox="1"/>
+          <p:nvPr/>
+        </p:nvSpPr>
+        <p:spPr>
+          <a:xfrm>
+            <a:off x="1097280" y="731520"/>
+            <a:ext cx="3657600" cy="365760"/>
+          </a:xfrm>
+          <a:prstGeom prst="rect">
+            <a:avLst/>
+          </a:prstGeom>
+          <a:noFill/>
+        </p:spPr>
+        <p:txBody>
+          <a:bodyPr wrap="none">
+            <a:spAutoFit/>
+          </a:bodyPr>
+          <a:lstStyle/>
+          <a:p>
+            <a:pPr algn="l">
+              <a:defRPr sz="1000" b="1">
+                <a:solidFill>
+                  <a:srgbClr val="34495E"/>
+                </a:solidFill>
+                <a:latin typeface="Calibri"/>
+              </a:defRPr>
+            </a:pPr>
+            <a:r>
+              <a:t>📊  MILESTONE</a:t>
+            </a:r>
+          </a:p>
+        </p:txBody>
+      </p:sp>
+      <p:sp>
+        <p:nvSpPr>
+          <p:cNvPr id="4" name="TextBox 3"/>
+          <p:cNvSpPr txBox="1"/>
+          <p:nvPr/>
+        </p:nvSpPr>
+        <p:spPr>
+          <a:xfrm>
+            <a:off x="1097280" y="1188720"/>
+            <a:ext cx="9966960" cy="731520"/>
+          </a:xfrm>
+          <a:prstGeom prst="rect">
+            <a:avLst/>
+          </a:prstGeom>
+          <a:noFill/>
+        </p:spPr>
+        <p:txBody>
+          <a:bodyPr wrap="square">
+            <a:spAutoFit/>
+          </a:bodyPr>
+          <a:lstStyle/>
+          <a:p>
+            <a:pPr algn="l">
+              <a:defRPr sz="3200" b="1" i="0">
+                <a:solidFill>
+                  <a:srgbClr val="34495E"/>
+                </a:solidFill>
+                <a:latin typeface="Calibri"/>
+              </a:defRPr>
+            </a:pPr>
+            <a:r>
+              <a:t>AI Operations Scale</a:t>
+            </a:r>
+          </a:p>
+        </p:txBody>
+      </p:sp>
+      <p:sp>
+        <p:nvSpPr>
+          <p:cNvPr id="5" name="TextBox 4"/>
+          <p:cNvSpPr txBox="1"/>
+          <p:nvPr/>
+        </p:nvSpPr>
+        <p:spPr>
+          <a:xfrm>
+            <a:off x="1097280" y="2103120"/>
+            <a:ext cx="4572000" cy="822960"/>
+          </a:xfrm>
+          <a:prstGeom prst="rect">
+            <a:avLst/>
+          </a:prstGeom>
+          <a:noFill/>
+        </p:spPr>
+        <p:txBody>
+          <a:bodyPr wrap="square">
+            <a:spAutoFit/>
+          </a:bodyPr>
+          <a:lstStyle/>
+          <a:p>
+            <a:pPr algn="l">
+              <a:defRPr sz="5200" b="1" i="0">
+                <a:solidFill>
+                  <a:srgbClr val="34495E"/>
+                </a:solidFill>
+                <a:latin typeface="Calibri"/>
+              </a:defRPr>
+            </a:pPr>
+            <a:r>
+              <a:t>1,000+</a:t>
+            </a:r>
+          </a:p>
+        </p:txBody>
+      </p:sp>
+      <p:sp>
+        <p:nvSpPr>
+          <p:cNvPr id="6" name="TextBox 5"/>
+          <p:cNvSpPr txBox="1"/>
+          <p:nvPr/>
+        </p:nvSpPr>
+        <p:spPr>
+          <a:xfrm>
+            <a:off x="1097280" y="2926080"/>
+            <a:ext cx="4572000" cy="365760"/>
+          </a:xfrm>
+          <a:prstGeom prst="rect">
+            <a:avLst/>
+          </a:prstGeom>
+          <a:noFill/>
+        </p:spPr>
+        <p:txBody>
+          <a:bodyPr wrap="square">
+            <a:spAutoFit/>
+          </a:bodyPr>
+          <a:lstStyle/>
+          <a:p>
+            <a:pPr algn="l">
+              <a:defRPr sz="1100" b="0" i="0">
+                <a:solidFill>
+                  <a:srgbClr val="8F95A3"/>
+                </a:solidFill>
+                <a:latin typeface="Calibri"/>
+              </a:defRPr>
+            </a:pPr>
+            <a:r>
+              <a:t>OKRs Audited Daily</a:t>
+            </a:r>
+          </a:p>
+        </p:txBody>
+      </p:sp>
+      <p:sp>
+        <p:nvSpPr>
+          <p:cNvPr id="7" name="TextBox 6"/>
+          <p:cNvSpPr txBox="1"/>
+          <p:nvPr/>
+        </p:nvSpPr>
+        <p:spPr>
+          <a:xfrm>
+            <a:off x="1097280" y="3566160"/>
+            <a:ext cx="9966960" cy="457200"/>
+          </a:xfrm>
+          <a:prstGeom prst="rect">
+            <a:avLst/>
+          </a:prstGeom>
+          <a:noFill/>
+        </p:spPr>
+        <p:txBody>
+          <a:bodyPr wrap="square">
+            <a:spAutoFit/>
+          </a:bodyPr>
+          <a:lstStyle/>
+          <a:p>
+            <a:pPr algn="l">
+              <a:defRPr sz="1800" b="1" i="0">
+                <a:solidFill>
+                  <a:srgbClr val="FFFFFF"/>
+                </a:solidFill>
+                <a:latin typeface="Calibri"/>
+              </a:defRPr>
+            </a:pPr>
+            <a:r>
+              <a:t>OKR Auditor Achievement</a:t>
+            </a:r>
+          </a:p>
+        </p:txBody>
+      </p:sp>
+      <p:sp>
+        <p:nvSpPr>
+          <p:cNvPr id="8" name="TextBox 7"/>
+          <p:cNvSpPr txBox="1"/>
+          <p:nvPr/>
+        </p:nvSpPr>
+        <p:spPr>
+          <a:xfrm>
+            <a:off x="1097280" y="4206240"/>
+            <a:ext cx="9966960" cy="1371600"/>
+          </a:xfrm>
+          <a:prstGeom prst="rect">
+            <a:avLst/>
+          </a:prstGeom>
+          <a:noFill/>
+        </p:spPr>
+        <p:txBody>
+          <a:bodyPr wrap="square">
+            <a:spAutoFit/>
+          </a:bodyPr>
+          <a:lstStyle/>
+          <a:p>
+            <a:pPr algn="l">
+              <a:defRPr sz="1500" b="0" i="0">
+                <a:solidFill>
+                  <a:srgbClr val="E2E2EA"/>
+                </a:solidFill>
+                <a:latin typeface="Calibri"/>
+              </a:defRPr>
+            </a:pPr>
+            <a:r>
+              <a:t>AI system processing massive scale of individual objectives</a:t>
+            </a:r>
+          </a:p>
+        </p:txBody>
+      </p:sp>
+    </p:spTree>
+  </p:cSld>
+  <p:clrMapOvr>
+    <a:masterClrMapping/>
+  </p:clrMapOvr>
+</p:sld>
+</file>
+
+<file path=ppt/slides/slide18.xml><?xml version="1.0" encoding="utf-8"?>
+<p:sld xmlns:a="http://schemas.openxmlformats.org/drawingml/2006/main" xmlns:p="http://schemas.openxmlformats.org/presentationml/2006/main" xmlns:r="http://schemas.openxmlformats.org/officeDocument/2006/relationships">
+  <p:cSld>
+    <p:bg>
+      <p:bgPr>
+        <a:solidFill>
+          <a:srgbClr val="08080C"/>
+        </a:solidFill>
+        <a:effectLst/>
+      </p:bgPr>
+    </p:bg>
+    <p:spTree>
+      <p:nvGrpSpPr>
+        <p:cNvPr id="1" name=""/>
+        <p:cNvGrpSpPr/>
+        <p:nvPr/>
+      </p:nvGrpSpPr>
+      <p:grpSpPr/>
+      <p:sp>
+        <p:nvSpPr>
+          <p:cNvPr id="2" name="Rectangle 1"/>
+          <p:cNvSpPr/>
+          <p:nvPr/>
+        </p:nvSpPr>
+        <p:spPr>
+          <a:xfrm>
+            <a:off x="0" y="365760"/>
+            <a:ext cx="12191695" cy="54864"/>
+          </a:xfrm>
+          <a:prstGeom prst="rect">
+            <a:avLst/>
+          </a:prstGeom>
+          <a:solidFill>
+            <a:srgbClr val="9B59B6"/>
+          </a:solidFill>
+          <a:ln>
+            <a:noFill/>
+          </a:ln>
+        </p:spPr>
+        <p:style>
+          <a:lnRef idx="1">
+            <a:schemeClr val="accent1"/>
+          </a:lnRef>
+          <a:fillRef idx="3">
+            <a:schemeClr val="accent1"/>
+          </a:fillRef>
+          <a:effectRef idx="2">
+            <a:schemeClr val="accent1"/>
+          </a:effectRef>
+          <a:fontRef idx="minor">
+            <a:schemeClr val="lt1"/>
+          </a:fontRef>
+        </p:style>
+        <p:txBody>
+          <a:bodyPr rtlCol="0" anchor="ctr"/>
+          <a:lstStyle/>
+          <a:p>
+            <a:pPr algn="ctr"/>
+          </a:p>
+        </p:txBody>
+      </p:sp>
+      <p:sp>
+        <p:nvSpPr>
+          <p:cNvPr id="3" name="TextBox 2"/>
+          <p:cNvSpPr txBox="1"/>
+          <p:nvPr/>
+        </p:nvSpPr>
+        <p:spPr>
+          <a:xfrm>
+            <a:off x="1097280" y="731520"/>
+            <a:ext cx="3657600" cy="365760"/>
+          </a:xfrm>
+          <a:prstGeom prst="rect">
+            <a:avLst/>
+          </a:prstGeom>
+          <a:noFill/>
+        </p:spPr>
+        <p:txBody>
+          <a:bodyPr wrap="none">
+            <a:spAutoFit/>
+          </a:bodyPr>
+          <a:lstStyle/>
+          <a:p>
+            <a:pPr algn="l">
+              <a:defRPr sz="1000" b="1">
+                <a:solidFill>
+                  <a:srgbClr val="9B59B6"/>
+                </a:solidFill>
+                <a:latin typeface="Calibri"/>
+              </a:defRPr>
+            </a:pPr>
+            <a:r>
+              <a:t>🧘  OFFICE LIFE</a:t>
+            </a:r>
+          </a:p>
+        </p:txBody>
+      </p:sp>
+      <p:sp>
+        <p:nvSpPr>
+          <p:cNvPr id="4" name="TextBox 3"/>
+          <p:cNvSpPr txBox="1"/>
+          <p:nvPr/>
+        </p:nvSpPr>
+        <p:spPr>
+          <a:xfrm>
+            <a:off x="1097280" y="1188720"/>
+            <a:ext cx="9966960" cy="731520"/>
+          </a:xfrm>
+          <a:prstGeom prst="rect">
+            <a:avLst/>
+          </a:prstGeom>
+          <a:noFill/>
+        </p:spPr>
+        <p:txBody>
+          <a:bodyPr wrap="square">
+            <a:spAutoFit/>
+          </a:bodyPr>
+          <a:lstStyle/>
+          <a:p>
+            <a:pPr algn="l">
+              <a:defRPr sz="3200" b="1" i="0">
+                <a:solidFill>
+                  <a:srgbClr val="9B59B6"/>
+                </a:solidFill>
+                <a:latin typeface="Calibri"/>
+              </a:defRPr>
+            </a:pPr>
+            <a:r>
+              <a:t>Wellness Culture</a:t>
             </a:r>
           </a:p>
         </p:txBody>
@@ -3428,7 +6005,328 @@
               </a:defRPr>
             </a:pPr>
             <a:r>
-              <a:t>Team Appreciation Thursday</a:t>
+              <a:t>Daily Yoga Sessions</a:t>
+            </a:r>
+          </a:p>
+        </p:txBody>
+      </p:sp>
+      <p:sp>
+        <p:nvSpPr>
+          <p:cNvPr id="6" name="TextBox 5"/>
+          <p:cNvSpPr txBox="1"/>
+          <p:nvPr/>
+        </p:nvSpPr>
+        <p:spPr>
+          <a:xfrm>
+            <a:off x="1371600" y="2743200"/>
+            <a:ext cx="9692640" cy="1828800"/>
+          </a:xfrm>
+          <a:prstGeom prst="rect">
+            <a:avLst/>
+          </a:prstGeom>
+          <a:noFill/>
+        </p:spPr>
+        <p:txBody>
+          <a:bodyPr wrap="square">
+            <a:spAutoFit/>
+          </a:bodyPr>
+          <a:lstStyle/>
+          <a:p>
+            <a:pPr algn="l">
+              <a:defRPr sz="1500" b="0" i="1">
+                <a:solidFill>
+                  <a:srgbClr val="E2E2EA"/>
+                </a:solidFill>
+                <a:latin typeface="Calibri"/>
+              </a:defRPr>
+            </a:pPr>
+            <a:r>
+              <a:t>"Daily yoga at 13:10 CET - building healthy habits together"</a:t>
+            </a:r>
+          </a:p>
+        </p:txBody>
+      </p:sp>
+      <p:sp>
+        <p:nvSpPr>
+          <p:cNvPr id="7" name="TextBox 6"/>
+          <p:cNvSpPr txBox="1"/>
+          <p:nvPr/>
+        </p:nvSpPr>
+        <p:spPr>
+          <a:xfrm>
+            <a:off x="1097280" y="4754880"/>
+            <a:ext cx="9966960" cy="365760"/>
+          </a:xfrm>
+          <a:prstGeom prst="rect">
+            <a:avLst/>
+          </a:prstGeom>
+          <a:noFill/>
+        </p:spPr>
+        <p:txBody>
+          <a:bodyPr wrap="square">
+            <a:spAutoFit/>
+          </a:bodyPr>
+          <a:lstStyle/>
+          <a:p>
+            <a:pPr algn="l">
+              <a:defRPr sz="1400" b="0" i="0">
+                <a:solidFill>
+                  <a:srgbClr val="8F95A3"/>
+                </a:solidFill>
+                <a:latin typeface="Calibri"/>
+              </a:defRPr>
+            </a:pPr>
+            <a:r>
+              <a:t>— Anna Kolyada</a:t>
+            </a:r>
+          </a:p>
+        </p:txBody>
+      </p:sp>
+      <p:sp>
+        <p:nvSpPr>
+          <p:cNvPr id="8" name="TextBox 7"/>
+          <p:cNvSpPr txBox="1"/>
+          <p:nvPr/>
+        </p:nvSpPr>
+        <p:spPr>
+          <a:xfrm>
+            <a:off x="1097280" y="5212080"/>
+            <a:ext cx="9966960" cy="365760"/>
+          </a:xfrm>
+          <a:prstGeom prst="rect">
+            <a:avLst/>
+          </a:prstGeom>
+          <a:noFill/>
+        </p:spPr>
+        <p:txBody>
+          <a:bodyPr wrap="square">
+            <a:spAutoFit/>
+          </a:bodyPr>
+          <a:lstStyle/>
+          <a:p>
+            <a:pPr algn="l">
+              <a:defRPr sz="1400" b="1" i="0">
+                <a:solidFill>
+                  <a:srgbClr val="9B59B6"/>
+                </a:solidFill>
+                <a:latin typeface="Calibri"/>
+              </a:defRPr>
+            </a:pPr>
+            <a:r>
+              <a:t>positive</a:t>
+            </a:r>
+          </a:p>
+        </p:txBody>
+      </p:sp>
+      <p:sp>
+        <p:nvSpPr>
+          <p:cNvPr id="9" name="TextBox 8"/>
+          <p:cNvSpPr txBox="1"/>
+          <p:nvPr/>
+        </p:nvSpPr>
+        <p:spPr>
+          <a:xfrm>
+            <a:off x="1097280" y="5760720"/>
+            <a:ext cx="9966960" cy="274320"/>
+          </a:xfrm>
+          <a:prstGeom prst="rect">
+            <a:avLst/>
+          </a:prstGeom>
+          <a:noFill/>
+        </p:spPr>
+        <p:txBody>
+          <a:bodyPr wrap="square">
+            <a:spAutoFit/>
+          </a:bodyPr>
+          <a:lstStyle/>
+          <a:p>
+            <a:pPr algn="l">
+              <a:defRPr sz="1100" b="0" i="0">
+                <a:solidFill>
+                  <a:srgbClr val="5C6270"/>
+                </a:solidFill>
+                <a:latin typeface="Calibri"/>
+              </a:defRPr>
+            </a:pPr>
+            <a:r>
+              <a:t>office culture</a:t>
+            </a:r>
+          </a:p>
+        </p:txBody>
+      </p:sp>
+    </p:spTree>
+  </p:cSld>
+  <p:clrMapOvr>
+    <a:masterClrMapping/>
+  </p:clrMapOvr>
+</p:sld>
+</file>
+
+<file path=ppt/slides/slide19.xml><?xml version="1.0" encoding="utf-8"?>
+<p:sld xmlns:a="http://schemas.openxmlformats.org/drawingml/2006/main" xmlns:p="http://schemas.openxmlformats.org/presentationml/2006/main" xmlns:r="http://schemas.openxmlformats.org/officeDocument/2006/relationships">
+  <p:cSld>
+    <p:bg>
+      <p:bgPr>
+        <a:solidFill>
+          <a:srgbClr val="08080C"/>
+        </a:solidFill>
+        <a:effectLst/>
+      </p:bgPr>
+    </p:bg>
+    <p:spTree>
+      <p:nvGrpSpPr>
+        <p:cNvPr id="1" name=""/>
+        <p:cNvGrpSpPr/>
+        <p:nvPr/>
+      </p:nvGrpSpPr>
+      <p:grpSpPr/>
+      <p:sp>
+        <p:nvSpPr>
+          <p:cNvPr id="2" name="Rectangle 1"/>
+          <p:cNvSpPr/>
+          <p:nvPr/>
+        </p:nvSpPr>
+        <p:spPr>
+          <a:xfrm>
+            <a:off x="0" y="365760"/>
+            <a:ext cx="12191695" cy="54864"/>
+          </a:xfrm>
+          <a:prstGeom prst="rect">
+            <a:avLst/>
+          </a:prstGeom>
+          <a:solidFill>
+            <a:srgbClr val="E67E22"/>
+          </a:solidFill>
+          <a:ln>
+            <a:noFill/>
+          </a:ln>
+        </p:spPr>
+        <p:style>
+          <a:lnRef idx="1">
+            <a:schemeClr val="accent1"/>
+          </a:lnRef>
+          <a:fillRef idx="3">
+            <a:schemeClr val="accent1"/>
+          </a:fillRef>
+          <a:effectRef idx="2">
+            <a:schemeClr val="accent1"/>
+          </a:effectRef>
+          <a:fontRef idx="minor">
+            <a:schemeClr val="lt1"/>
+          </a:fontRef>
+        </p:style>
+        <p:txBody>
+          <a:bodyPr rtlCol="0" anchor="ctr"/>
+          <a:lstStyle/>
+          <a:p>
+            <a:pPr algn="ctr"/>
+          </a:p>
+        </p:txBody>
+      </p:sp>
+      <p:sp>
+        <p:nvSpPr>
+          <p:cNvPr id="3" name="TextBox 2"/>
+          <p:cNvSpPr txBox="1"/>
+          <p:nvPr/>
+        </p:nvSpPr>
+        <p:spPr>
+          <a:xfrm>
+            <a:off x="1097280" y="731520"/>
+            <a:ext cx="3657600" cy="365760"/>
+          </a:xfrm>
+          <a:prstGeom prst="rect">
+            <a:avLst/>
+          </a:prstGeom>
+          <a:noFill/>
+        </p:spPr>
+        <p:txBody>
+          <a:bodyPr wrap="none">
+            <a:spAutoFit/>
+          </a:bodyPr>
+          <a:lstStyle/>
+          <a:p>
+            <a:pPr algn="l">
+              <a:defRPr sz="1000" b="1">
+                <a:solidFill>
+                  <a:srgbClr val="E67E22"/>
+                </a:solidFill>
+                <a:latin typeface="Calibri"/>
+              </a:defRPr>
+            </a:pPr>
+            <a:r>
+              <a:t>🚢  WEEKLY RITUAL</a:t>
+            </a:r>
+          </a:p>
+        </p:txBody>
+      </p:sp>
+      <p:sp>
+        <p:nvSpPr>
+          <p:cNvPr id="4" name="TextBox 3"/>
+          <p:cNvSpPr txBox="1"/>
+          <p:nvPr/>
+        </p:nvSpPr>
+        <p:spPr>
+          <a:xfrm>
+            <a:off x="1097280" y="1188720"/>
+            <a:ext cx="9966960" cy="731520"/>
+          </a:xfrm>
+          <a:prstGeom prst="rect">
+            <a:avLst/>
+          </a:prstGeom>
+          <a:noFill/>
+        </p:spPr>
+        <p:txBody>
+          <a:bodyPr wrap="square">
+            <a:spAutoFit/>
+          </a:bodyPr>
+          <a:lstStyle/>
+          <a:p>
+            <a:pPr algn="l">
+              <a:defRPr sz="3200" b="1" i="0">
+                <a:solidFill>
+                  <a:srgbClr val="E67E22"/>
+                </a:solidFill>
+                <a:latin typeface="Calibri"/>
+              </a:defRPr>
+            </a:pPr>
+            <a:r>
+              <a:t>Build Culture</a:t>
+            </a:r>
+          </a:p>
+        </p:txBody>
+      </p:sp>
+      <p:sp>
+        <p:nvSpPr>
+          <p:cNvPr id="5" name="TextBox 4"/>
+          <p:cNvSpPr txBox="1"/>
+          <p:nvPr/>
+        </p:nvSpPr>
+        <p:spPr>
+          <a:xfrm>
+            <a:off x="1097280" y="2103120"/>
+            <a:ext cx="9966960" cy="457200"/>
+          </a:xfrm>
+          <a:prstGeom prst="rect">
+            <a:avLst/>
+          </a:prstGeom>
+          <a:noFill/>
+        </p:spPr>
+        <p:txBody>
+          <a:bodyPr wrap="square">
+            <a:spAutoFit/>
+          </a:bodyPr>
+          <a:lstStyle/>
+          <a:p>
+            <a:pPr algn="l">
+              <a:defRPr sz="1800" b="1" i="0">
+                <a:solidFill>
+                  <a:srgbClr val="FFFFFF"/>
+                </a:solidFill>
+                <a:latin typeface="Calibri"/>
+              </a:defRPr>
+            </a:pPr>
+            <a:r>
+              <a:t>Build. Ship. Improve.</a:t>
             </a:r>
           </a:p>
         </p:txBody>
@@ -3464,7 +6362,7 @@
               </a:defRPr>
             </a:pPr>
             <a:r>
-              <a:t>Who inspired you this week?</a:t>
+              <a:t>Shift from requirements to pull requests</a:t>
             </a:r>
           </a:p>
         </p:txBody>
@@ -3500,7 +6398,7 @@
               </a:defRPr>
             </a:pPr>
             <a:r>
-              <a:t>Share some claps in #claps!</a:t>
+              <a:t>Action over analysis paralysis</a:t>
             </a:r>
           </a:p>
         </p:txBody>
@@ -3536,7 +6434,7 @@
               </a:defRPr>
             </a:pPr>
             <a:r>
-              <a:t>We work TOGETHER to SERVE OTHERS</a:t>
+              <a:t>EXECUTION EXCELLENCE</a:t>
             </a:r>
           </a:p>
         </p:txBody>
@@ -3572,7 +6470,7 @@
               </a:defRPr>
             </a:pPr>
             <a:r>
-              <a:t>claps</a:t>
+              <a:t>company culture</a:t>
             </a:r>
           </a:p>
         </p:txBody>
@@ -3677,7 +6575,7 @@
               </a:defRPr>
             </a:pPr>
             <a:r>
-              <a:t>🎉  CELEBRATION</a:t>
+              <a:t>🎂  CELEBRATION</a:t>
             </a:r>
           </a:p>
         </p:txBody>
@@ -3713,7 +6611,7 @@
               </a:defRPr>
             </a:pPr>
             <a:r>
-              <a:t>Birthday Celebrations!</a:t>
+              <a:t>Birthday Celebration</a:t>
             </a:r>
           </a:p>
         </p:txBody>
@@ -3749,7 +6647,7 @@
               </a:defRPr>
             </a:pPr>
             <a:r>
-              <a:t>Team Members</a:t>
+              <a:t>Alexandr Sikorsky</a:t>
             </a:r>
           </a:p>
         </p:txBody>
@@ -3821,7 +6719,7 @@
               </a:defRPr>
             </a:pPr>
             <a:r>
-              <a:t>Happy Birthday to our amazing team members! 🎂</a:t>
+              <a:t>Celebrating another year of awesome! Thank you for being such a fantastic part of our team.</a:t>
             </a:r>
           </a:p>
         </p:txBody>
@@ -3857,7 +6755,7 @@
               </a:defRPr>
             </a:pPr>
             <a:r>
-              <a:t>Wishing you an incredible year ahead!</a:t>
+              <a:t>Making work brighter with ideas, humor, and dedication</a:t>
             </a:r>
           </a:p>
         </p:txBody>
@@ -3903,7 +6801,7 @@
             <a:avLst/>
           </a:prstGeom>
           <a:solidFill>
-            <a:srgbClr val="4CAF50"/>
+            <a:srgbClr val="4ECDC4"/>
           </a:solidFill>
           <a:ln>
             <a:noFill/>
@@ -3956,7 +6854,7 @@
             <a:pPr algn="l">
               <a:defRPr sz="1000" b="1">
                 <a:solidFill>
-                  <a:srgbClr val="4CAF50"/>
+                  <a:srgbClr val="4ECDC4"/>
                 </a:solidFill>
                 <a:latin typeface="Calibri"/>
               </a:defRPr>
@@ -3992,7 +6890,7 @@
             <a:pPr algn="l">
               <a:defRPr sz="3200" b="1" i="0">
                 <a:solidFill>
-                  <a:srgbClr val="4CAF50"/>
+                  <a:srgbClr val="4ECDC4"/>
                 </a:solidFill>
                 <a:latin typeface="Calibri"/>
               </a:defRPr>
@@ -4028,13 +6926,13 @@
             <a:pPr algn="l">
               <a:defRPr sz="4800" b="1" i="0">
                 <a:solidFill>
-                  <a:srgbClr val="4CAF50"/>
-                </a:solidFill>
-                <a:latin typeface="Calibri"/>
-              </a:defRPr>
-            </a:pPr>
-            <a:r>
-              <a:t>98</a:t>
+                  <a:srgbClr val="4ECDC4"/>
+                </a:solidFill>
+                <a:latin typeface="Calibri"/>
+              </a:defRPr>
+            </a:pPr>
+            <a:r>
+              <a:t>1</a:t>
             </a:r>
           </a:p>
         </p:txBody>
@@ -4070,7 +6968,7 @@
               </a:defRPr>
             </a:pPr>
             <a:r>
-              <a:t>reactions</a:t>
+              <a:t>click deployment</a:t>
             </a:r>
           </a:p>
         </p:txBody>
@@ -4106,7 +7004,7 @@
               </a:defRPr>
             </a:pPr>
             <a:r>
-              <a:t>by Gleb Krahotkin &amp; DevOps Team</a:t>
+              <a:t>by Gleb Krahotkin</a:t>
             </a:r>
           </a:p>
         </p:txBody>
@@ -4142,7 +7040,7 @@
               </a:defRPr>
             </a:pPr>
             <a:r>
-              <a:t>Coolify Platform Launch Success</a:t>
+              <a:t>Coolify Platform Launched</a:t>
             </a:r>
           </a:p>
         </p:txBody>
@@ -4178,7 +7076,7 @@
               </a:defRPr>
             </a:pPr>
             <a:r>
-              <a:t>Our DevOps team launched Coolify - a revolutionary one-click deployment service that makes app deployment effortless for everyone.</a:t>
+              <a:t>Revolutionary deployment service now live for all teams</a:t>
             </a:r>
           </a:p>
         </p:txBody>
@@ -4214,7 +7112,7 @@
               </a:defRPr>
             </a:pPr>
             <a:r>
-              <a:t>💬 "Innovation that empowers the entire team to deploy faster and easier!"</a:t>
+              <a:t>💬 "Deploy applications in just a few clicks with our new internal platform"</a:t>
             </a:r>
           </a:p>
         </p:txBody>
@@ -4260,7 +7158,7 @@
             <a:avLst/>
           </a:prstGeom>
           <a:solidFill>
-            <a:srgbClr val="9C27B0"/>
+            <a:srgbClr val="9B59B6"/>
           </a:solidFill>
           <a:ln>
             <a:noFill/>
@@ -4313,13 +7211,13 @@
             <a:pPr algn="l">
               <a:defRPr sz="1000" b="1">
                 <a:solidFill>
-                  <a:srgbClr val="9C27B0"/>
-                </a:solidFill>
-                <a:latin typeface="Calibri"/>
-              </a:defRPr>
-            </a:pPr>
-            <a:r>
-              <a:t>🎓  EVENT</a:t>
+                  <a:srgbClr val="9B59B6"/>
+                </a:solidFill>
+                <a:latin typeface="Calibri"/>
+              </a:defRPr>
+            </a:pPr>
+            <a:r>
+              <a:t>👏  CLAPS</a:t>
             </a:r>
           </a:p>
         </p:txBody>
@@ -4349,13 +7247,13 @@
             <a:pPr algn="l">
               <a:defRPr sz="3200" b="1" i="0">
                 <a:solidFill>
-                  <a:srgbClr val="9C27B0"/>
-                </a:solidFill>
-                <a:latin typeface="Calibri"/>
-              </a:defRPr>
-            </a:pPr>
-            <a:r>
-              <a:t>Knowledge Sharing Win</a:t>
+                  <a:srgbClr val="9B59B6"/>
+                </a:solidFill>
+                <a:latin typeface="Calibri"/>
+              </a:defRPr>
+            </a:pPr>
+            <a:r>
+              <a:t>Team Recognition</a:t>
             </a:r>
           </a:p>
         </p:txBody>
@@ -4369,21 +7267,93 @@
         <p:spPr>
           <a:xfrm>
             <a:off x="1097280" y="2103120"/>
-            <a:ext cx="9966960" cy="548640"/>
-          </a:xfrm>
-          <a:prstGeom prst="rect">
-            <a:avLst/>
-          </a:prstGeom>
-          <a:noFill/>
-        </p:spPr>
-        <p:txBody>
-          <a:bodyPr wrap="square">
-            <a:spAutoFit/>
-          </a:bodyPr>
-          <a:lstStyle/>
-          <a:p>
-            <a:pPr algn="l">
-              <a:defRPr sz="2200" b="1" i="0">
+            <a:ext cx="2743200" cy="548640"/>
+          </a:xfrm>
+          <a:prstGeom prst="rect">
+            <a:avLst/>
+          </a:prstGeom>
+          <a:noFill/>
+        </p:spPr>
+        <p:txBody>
+          <a:bodyPr wrap="square">
+            <a:spAutoFit/>
+          </a:bodyPr>
+          <a:lstStyle/>
+          <a:p>
+            <a:pPr algn="l">
+              <a:defRPr sz="2800" b="1" i="0">
+                <a:solidFill>
+                  <a:srgbClr val="9B59B6"/>
+                </a:solidFill>
+                <a:latin typeface="Calibri"/>
+              </a:defRPr>
+            </a:pPr>
+            <a:r>
+              <a:t>50</a:t>
+            </a:r>
+          </a:p>
+        </p:txBody>
+      </p:sp>
+      <p:sp>
+        <p:nvSpPr>
+          <p:cNvPr id="6" name="TextBox 5"/>
+          <p:cNvSpPr txBox="1"/>
+          <p:nvPr/>
+        </p:nvSpPr>
+        <p:spPr>
+          <a:xfrm>
+            <a:off x="1097280" y="2651760"/>
+            <a:ext cx="9966960" cy="365760"/>
+          </a:xfrm>
+          <a:prstGeom prst="rect">
+            <a:avLst/>
+          </a:prstGeom>
+          <a:noFill/>
+        </p:spPr>
+        <p:txBody>
+          <a:bodyPr wrap="square">
+            <a:spAutoFit/>
+          </a:bodyPr>
+          <a:lstStyle/>
+          <a:p>
+            <a:pPr algn="l">
+              <a:defRPr sz="1400" b="0" i="0">
+                <a:solidFill>
+                  <a:srgbClr val="E2E2EA"/>
+                </a:solidFill>
+                <a:latin typeface="Calibri"/>
+              </a:defRPr>
+            </a:pPr>
+            <a:r>
+              <a:t>from pavel.savinskiy</a:t>
+            </a:r>
+          </a:p>
+        </p:txBody>
+      </p:sp>
+      <p:sp>
+        <p:nvSpPr>
+          <p:cNvPr id="7" name="TextBox 6"/>
+          <p:cNvSpPr txBox="1"/>
+          <p:nvPr/>
+        </p:nvSpPr>
+        <p:spPr>
+          <a:xfrm>
+            <a:off x="1097280" y="3108960"/>
+            <a:ext cx="9966960" cy="365760"/>
+          </a:xfrm>
+          <a:prstGeom prst="rect">
+            <a:avLst/>
+          </a:prstGeom>
+          <a:noFill/>
+        </p:spPr>
+        <p:txBody>
+          <a:bodyPr wrap="square">
+            <a:spAutoFit/>
+          </a:bodyPr>
+          <a:lstStyle/>
+          <a:p>
+            <a:pPr algn="l">
+              <a:defRPr sz="1400" b="1" i="0">
                 <a:solidFill>
                   <a:srgbClr val="FFFFFF"/>
                 </a:solidFill>
@@ -4391,71 +7361,35 @@
               </a:defRPr>
             </a:pPr>
             <a:r>
-              <a:t>11th Lunch &amp; Learn Session</a:t>
-            </a:r>
-          </a:p>
-        </p:txBody>
-      </p:sp>
-      <p:sp>
-        <p:nvSpPr>
-          <p:cNvPr id="6" name="TextBox 5"/>
-          <p:cNvSpPr txBox="1"/>
-          <p:nvPr/>
-        </p:nvSpPr>
-        <p:spPr>
-          <a:xfrm>
-            <a:off x="1097280" y="2743200"/>
-            <a:ext cx="9966960" cy="365760"/>
-          </a:xfrm>
-          <a:prstGeom prst="rect">
-            <a:avLst/>
-          </a:prstGeom>
-          <a:noFill/>
-        </p:spPr>
-        <p:txBody>
-          <a:bodyPr wrap="square">
-            <a:spAutoFit/>
-          </a:bodyPr>
-          <a:lstStyle/>
-          <a:p>
-            <a:pPr algn="l">
-              <a:defRPr sz="1400" b="1" i="0">
-                <a:solidFill>
-                  <a:srgbClr val="9C27B0"/>
-                </a:solidFill>
-                <a:latin typeface="Calibri"/>
-              </a:defRPr>
-            </a:pPr>
-            <a:r>
-              <a:t>Recently Completed</a:t>
-            </a:r>
-          </a:p>
-        </p:txBody>
-      </p:sp>
-      <p:sp>
-        <p:nvSpPr>
-          <p:cNvPr id="7" name="TextBox 6"/>
-          <p:cNvSpPr txBox="1"/>
-          <p:nvPr/>
-        </p:nvSpPr>
-        <p:spPr>
-          <a:xfrm>
-            <a:off x="1097280" y="3291840"/>
-            <a:ext cx="9966960" cy="1371600"/>
-          </a:xfrm>
-          <a:prstGeom prst="rect">
-            <a:avLst/>
-          </a:prstGeom>
-          <a:noFill/>
-        </p:spPr>
-        <p:txBody>
-          <a:bodyPr wrap="square">
-            <a:spAutoFit/>
-          </a:bodyPr>
-          <a:lstStyle/>
-          <a:p>
-            <a:pPr algn="l">
-              <a:defRPr sz="1500" b="0" i="0">
+              <a:t>to: sergeydesigner</a:t>
+            </a:r>
+          </a:p>
+        </p:txBody>
+      </p:sp>
+      <p:sp>
+        <p:nvSpPr>
+          <p:cNvPr id="8" name="TextBox 7"/>
+          <p:cNvSpPr txBox="1"/>
+          <p:nvPr/>
+        </p:nvSpPr>
+        <p:spPr>
+          <a:xfrm>
+            <a:off x="1097280" y="3749039"/>
+            <a:ext cx="9966960" cy="1097280"/>
+          </a:xfrm>
+          <a:prstGeom prst="rect">
+            <a:avLst/>
+          </a:prstGeom>
+          <a:noFill/>
+        </p:spPr>
+        <p:txBody>
+          <a:bodyPr wrap="square">
+            <a:spAutoFit/>
+          </a:bodyPr>
+          <a:lstStyle/>
+          <a:p>
+            <a:pPr algn="l">
+              <a:defRPr sz="1500" b="0" i="1">
                 <a:solidFill>
                   <a:srgbClr val="E2E2EA"/>
                 </a:solidFill>
@@ -4463,43 +7397,43 @@
               </a:defRPr>
             </a:pPr>
             <a:r>
-              <a:t>Timofey Levanov delivered an engaging presentation on fraud traffic detection, with recording and slides now available for all team members.</a:t>
-            </a:r>
-          </a:p>
-        </p:txBody>
-      </p:sp>
-      <p:sp>
-        <p:nvSpPr>
-          <p:cNvPr id="8" name="TextBox 7"/>
-          <p:cNvSpPr txBox="1"/>
-          <p:nvPr/>
-        </p:nvSpPr>
-        <p:spPr>
-          <a:xfrm>
-            <a:off x="1097280" y="5029200"/>
-            <a:ext cx="9966960" cy="365760"/>
-          </a:xfrm>
-          <a:prstGeom prst="rect">
-            <a:avLst/>
-          </a:prstGeom>
-          <a:noFill/>
-        </p:spPr>
-        <p:txBody>
-          <a:bodyPr wrap="square">
-            <a:spAutoFit/>
-          </a:bodyPr>
-          <a:lstStyle/>
-          <a:p>
-            <a:pPr algn="l">
-              <a:defRPr sz="1300" b="0" i="0">
-                <a:solidFill>
-                  <a:srgbClr val="8F95A3"/>
-                </a:solidFill>
-                <a:latin typeface="Calibri"/>
-              </a:defRPr>
-            </a:pPr>
-            <a:r>
-              <a:t>Organized by Katarzyna Raniszewska</a:t>
+              <a:t>"Outstanding design work and creative excellence"</a:t>
+            </a:r>
+          </a:p>
+        </p:txBody>
+      </p:sp>
+      <p:sp>
+        <p:nvSpPr>
+          <p:cNvPr id="9" name="TextBox 8"/>
+          <p:cNvSpPr txBox="1"/>
+          <p:nvPr/>
+        </p:nvSpPr>
+        <p:spPr>
+          <a:xfrm>
+            <a:off x="1097280" y="5120640"/>
+            <a:ext cx="9966960" cy="457200"/>
+          </a:xfrm>
+          <a:prstGeom prst="rect">
+            <a:avLst/>
+          </a:prstGeom>
+          <a:noFill/>
+        </p:spPr>
+        <p:txBody>
+          <a:bodyPr wrap="square">
+            <a:spAutoFit/>
+          </a:bodyPr>
+          <a:lstStyle/>
+          <a:p>
+            <a:pPr algn="l">
+              <a:defRPr sz="1200" b="1" i="0">
+                <a:solidFill>
+                  <a:srgbClr val="9B59B6"/>
+                </a:solidFill>
+                <a:latin typeface="Calibri"/>
+              </a:defRPr>
+            </a:pPr>
+            <a:r>
+              <a:t>EXCELLENCE · CREATIVITY</a:t>
             </a:r>
           </a:p>
         </p:txBody>
@@ -4545,7 +7479,7 @@
             <a:avLst/>
           </a:prstGeom>
           <a:solidFill>
-            <a:srgbClr val="FF9800"/>
+            <a:srgbClr val="E67E22"/>
           </a:solidFill>
           <a:ln>
             <a:noFill/>
@@ -4598,13 +7532,13 @@
             <a:pPr algn="l">
               <a:defRPr sz="1000" b="1">
                 <a:solidFill>
-                  <a:srgbClr val="FF9800"/>
-                </a:solidFill>
-                <a:latin typeface="Calibri"/>
-              </a:defRPr>
-            </a:pPr>
-            <a:r>
-              <a:t>👏  CLAPS</a:t>
+                  <a:srgbClr val="E67E22"/>
+                </a:solidFill>
+                <a:latin typeface="Calibri"/>
+              </a:defRPr>
+            </a:pPr>
+            <a:r>
+              <a:t>🔥  EVENT</a:t>
             </a:r>
           </a:p>
         </p:txBody>
@@ -4634,13 +7568,13 @@
             <a:pPr algn="l">
               <a:defRPr sz="3200" b="1" i="0">
                 <a:solidFill>
-                  <a:srgbClr val="FF9800"/>
-                </a:solidFill>
-                <a:latin typeface="Calibri"/>
-              </a:defRPr>
-            </a:pPr>
-            <a:r>
-              <a:t>Recognition Champions</a:t>
+                  <a:srgbClr val="E67E22"/>
+                </a:solidFill>
+                <a:latin typeface="Calibri"/>
+              </a:defRPr>
+            </a:pPr>
+            <a:r>
+              <a:t>Lunch &amp; Learn Success</a:t>
             </a:r>
           </a:p>
         </p:txBody>
@@ -4654,29 +7588,29 @@
         <p:spPr>
           <a:xfrm>
             <a:off x="1097280" y="2103120"/>
-            <a:ext cx="2743200" cy="548640"/>
-          </a:xfrm>
-          <a:prstGeom prst="rect">
-            <a:avLst/>
-          </a:prstGeom>
-          <a:noFill/>
-        </p:spPr>
-        <p:txBody>
-          <a:bodyPr wrap="square">
-            <a:spAutoFit/>
-          </a:bodyPr>
-          <a:lstStyle/>
-          <a:p>
-            <a:pPr algn="l">
-              <a:defRPr sz="2800" b="1" i="0">
-                <a:solidFill>
-                  <a:srgbClr val="FF9800"/>
-                </a:solidFill>
-                <a:latin typeface="Calibri"/>
-              </a:defRPr>
-            </a:pPr>
-            <a:r>
-              <a:t>50</a:t>
+            <a:ext cx="9966960" cy="548640"/>
+          </a:xfrm>
+          <a:prstGeom prst="rect">
+            <a:avLst/>
+          </a:prstGeom>
+          <a:noFill/>
+        </p:spPr>
+        <p:txBody>
+          <a:bodyPr wrap="square">
+            <a:spAutoFit/>
+          </a:bodyPr>
+          <a:lstStyle/>
+          <a:p>
+            <a:pPr algn="l">
+              <a:defRPr sz="2200" b="1" i="0">
+                <a:solidFill>
+                  <a:srgbClr val="FFFFFF"/>
+                </a:solidFill>
+                <a:latin typeface="Calibri"/>
+              </a:defRPr>
+            </a:pPr>
+            <a:r>
+              <a:t>11th Lunch &amp; Learn Session</a:t>
             </a:r>
           </a:p>
         </p:txBody>
@@ -4689,7 +7623,7 @@
         </p:nvSpPr>
         <p:spPr>
           <a:xfrm>
-            <a:off x="1097280" y="2651760"/>
+            <a:off x="1097280" y="2743200"/>
             <a:ext cx="9966960" cy="365760"/>
           </a:xfrm>
           <a:prstGeom prst="rect">
@@ -4704,7 +7638,43 @@
           <a:lstStyle/>
           <a:p>
             <a:pPr algn="l">
-              <a:defRPr sz="1400" b="0" i="0">
+              <a:defRPr sz="1400" b="1" i="0">
+                <a:solidFill>
+                  <a:srgbClr val="E67E22"/>
+                </a:solidFill>
+                <a:latin typeface="Calibri"/>
+              </a:defRPr>
+            </a:pPr>
+            <a:r>
+              <a:t>This Week</a:t>
+            </a:r>
+          </a:p>
+        </p:txBody>
+      </p:sp>
+      <p:sp>
+        <p:nvSpPr>
+          <p:cNvPr id="7" name="TextBox 6"/>
+          <p:cNvSpPr txBox="1"/>
+          <p:nvPr/>
+        </p:nvSpPr>
+        <p:spPr>
+          <a:xfrm>
+            <a:off x="1097280" y="3291840"/>
+            <a:ext cx="9966960" cy="1371600"/>
+          </a:xfrm>
+          <a:prstGeom prst="rect">
+            <a:avLst/>
+          </a:prstGeom>
+          <a:noFill/>
+        </p:spPr>
+        <p:txBody>
+          <a:bodyPr wrap="square">
+            <a:spAutoFit/>
+          </a:bodyPr>
+          <a:lstStyle/>
+          <a:p>
+            <a:pPr algn="l">
+              <a:defRPr sz="1500" b="0" i="0">
                 <a:solidFill>
                   <a:srgbClr val="E2E2EA"/>
                 </a:solidFill>
@@ -4712,20 +7682,20 @@
               </a:defRPr>
             </a:pPr>
             <a:r>
-              <a:t>from pavel.savinskiy</a:t>
-            </a:r>
-          </a:p>
-        </p:txBody>
-      </p:sp>
-      <p:sp>
-        <p:nvSpPr>
-          <p:cNvPr id="7" name="TextBox 6"/>
-          <p:cNvSpPr txBox="1"/>
-          <p:nvPr/>
-        </p:nvSpPr>
-        <p:spPr>
-          <a:xfrm>
-            <a:off x="1097280" y="3108960"/>
+              <a:t>Timofey Levanov presented on fraud traffic detection</a:t>
+            </a:r>
+          </a:p>
+        </p:txBody>
+      </p:sp>
+      <p:sp>
+        <p:nvSpPr>
+          <p:cNvPr id="8" name="TextBox 7"/>
+          <p:cNvSpPr txBox="1"/>
+          <p:nvPr/>
+        </p:nvSpPr>
+        <p:spPr>
+          <a:xfrm>
+            <a:off x="1097280" y="5029200"/>
             <a:ext cx="9966960" cy="365760"/>
           </a:xfrm>
           <a:prstGeom prst="rect">
@@ -4740,87 +7710,15 @@
           <a:lstStyle/>
           <a:p>
             <a:pPr algn="l">
-              <a:defRPr sz="1400" b="1" i="0">
-                <a:solidFill>
-                  <a:srgbClr val="FFFFFF"/>
-                </a:solidFill>
-                <a:latin typeface="Calibri"/>
-              </a:defRPr>
-            </a:pPr>
-            <a:r>
-              <a:t>to: sergeydesigner</a:t>
-            </a:r>
-          </a:p>
-        </p:txBody>
-      </p:sp>
-      <p:sp>
-        <p:nvSpPr>
-          <p:cNvPr id="8" name="TextBox 7"/>
-          <p:cNvSpPr txBox="1"/>
-          <p:nvPr/>
-        </p:nvSpPr>
-        <p:spPr>
-          <a:xfrm>
-            <a:off x="1097280" y="3749039"/>
-            <a:ext cx="9966960" cy="1097280"/>
-          </a:xfrm>
-          <a:prstGeom prst="rect">
-            <a:avLst/>
-          </a:prstGeom>
-          <a:noFill/>
-        </p:spPr>
-        <p:txBody>
-          <a:bodyPr wrap="square">
-            <a:spAutoFit/>
-          </a:bodyPr>
-          <a:lstStyle/>
-          <a:p>
-            <a:pPr algn="l">
-              <a:defRPr sz="1500" b="0" i="1">
-                <a:solidFill>
-                  <a:srgbClr val="E2E2EA"/>
-                </a:solidFill>
-                <a:latin typeface="Calibri"/>
-              </a:defRPr>
-            </a:pPr>
-            <a:r>
-              <a:t>"Outstanding design work and creative excellence"</a:t>
-            </a:r>
-          </a:p>
-        </p:txBody>
-      </p:sp>
-      <p:sp>
-        <p:nvSpPr>
-          <p:cNvPr id="9" name="TextBox 8"/>
-          <p:cNvSpPr txBox="1"/>
-          <p:nvPr/>
-        </p:nvSpPr>
-        <p:spPr>
-          <a:xfrm>
-            <a:off x="1097280" y="5120640"/>
-            <a:ext cx="9966960" cy="457200"/>
-          </a:xfrm>
-          <a:prstGeom prst="rect">
-            <a:avLst/>
-          </a:prstGeom>
-          <a:noFill/>
-        </p:spPr>
-        <p:txBody>
-          <a:bodyPr wrap="square">
-            <a:spAutoFit/>
-          </a:bodyPr>
-          <a:lstStyle/>
-          <a:p>
-            <a:pPr algn="l">
-              <a:defRPr sz="1200" b="1" i="0">
-                <a:solidFill>
-                  <a:srgbClr val="FF9800"/>
-                </a:solidFill>
-                <a:latin typeface="Calibri"/>
-              </a:defRPr>
-            </a:pPr>
-            <a:r>
-              <a:t>Excellence · Creativity</a:t>
+              <a:defRPr sz="1300" b="0" i="0">
+                <a:solidFill>
+                  <a:srgbClr val="8F95A3"/>
+                </a:solidFill>
+                <a:latin typeface="Calibri"/>
+              </a:defRPr>
+            </a:pPr>
+            <a:r>
+              <a:t>Organized by Katarzyna Raniszewska</a:t>
             </a:r>
           </a:p>
         </p:txBody>
@@ -4866,7 +7764,7 @@
             <a:avLst/>
           </a:prstGeom>
           <a:solidFill>
-            <a:srgbClr val="E91E63"/>
+            <a:srgbClr val="3498DB"/>
           </a:solidFill>
           <a:ln>
             <a:noFill/>
@@ -4919,7 +7817,7 @@
             <a:pPr algn="l">
               <a:defRPr sz="1000" b="1">
                 <a:solidFill>
-                  <a:srgbClr val="E91E63"/>
+                  <a:srgbClr val="3498DB"/>
                 </a:solidFill>
                 <a:latin typeface="Calibri"/>
               </a:defRPr>
@@ -4955,13 +7853,13 @@
             <a:pPr algn="l">
               <a:defRPr sz="3200" b="1" i="0">
                 <a:solidFill>
-                  <a:srgbClr val="E91E63"/>
-                </a:solidFill>
-                <a:latin typeface="Calibri"/>
-              </a:defRPr>
-            </a:pPr>
-            <a:r>
-              <a:t>Team Excellence</a:t>
+                  <a:srgbClr val="3498DB"/>
+                </a:solidFill>
+                <a:latin typeface="Calibri"/>
+              </a:defRPr>
+            </a:pPr>
+            <a:r>
+              <a:t>Individual Excellence</a:t>
             </a:r>
           </a:p>
         </p:txBody>
@@ -4991,7 +7889,7 @@
             <a:pPr algn="l">
               <a:defRPr sz="2800" b="1" i="0">
                 <a:solidFill>
-                  <a:srgbClr val="E91E63"/>
+                  <a:srgbClr val="3498DB"/>
                 </a:solidFill>
                 <a:latin typeface="Calibri"/>
               </a:defRPr>
@@ -5105,7 +8003,7 @@
               </a:defRPr>
             </a:pPr>
             <a:r>
-              <a:t>"Exceptional technical contributions and problem-solving"</a:t>
+              <a:t>"Exceptional performance and dedication"</a:t>
             </a:r>
           </a:p>
         </p:txBody>
@@ -5135,13 +8033,13 @@
             <a:pPr algn="l">
               <a:defRPr sz="1200" b="1" i="0">
                 <a:solidFill>
-                  <a:srgbClr val="E91E63"/>
-                </a:solidFill>
-                <a:latin typeface="Calibri"/>
-              </a:defRPr>
-            </a:pPr>
-            <a:r>
-              <a:t>Technical Excellence · Innovation</a:t>
+                  <a:srgbClr val="3498DB"/>
+                </a:solidFill>
+                <a:latin typeface="Calibri"/>
+              </a:defRPr>
+            </a:pPr>
+            <a:r>
+              <a:t>EXCELLENCE · DEDICATION</a:t>
             </a:r>
           </a:p>
         </p:txBody>
@@ -5187,7 +8085,7 @@
             <a:avLst/>
           </a:prstGeom>
           <a:solidFill>
-            <a:srgbClr val="2196F3"/>
+            <a:srgbClr val="27AE60"/>
           </a:solidFill>
           <a:ln>
             <a:noFill/>
@@ -5240,13 +8138,13 @@
             <a:pPr algn="l">
               <a:defRPr sz="1000" b="1">
                 <a:solidFill>
-                  <a:srgbClr val="2196F3"/>
-                </a:solidFill>
-                <a:latin typeface="Calibri"/>
-              </a:defRPr>
-            </a:pPr>
-            <a:r>
-              <a:t>🤝  CLAPS</a:t>
+                  <a:srgbClr val="27AE60"/>
+                </a:solidFill>
+                <a:latin typeface="Calibri"/>
+              </a:defRPr>
+            </a:pPr>
+            <a:r>
+              <a:t>📚  RECOMMENDED</a:t>
             </a:r>
           </a:p>
         </p:txBody>
@@ -5276,13 +8174,13 @@
             <a:pPr algn="l">
               <a:defRPr sz="3200" b="1" i="0">
                 <a:solidFill>
-                  <a:srgbClr val="2196F3"/>
-                </a:solidFill>
-                <a:latin typeface="Calibri"/>
-              </a:defRPr>
-            </a:pPr>
-            <a:r>
-              <a:t>Collaboration Power</a:t>
+                  <a:srgbClr val="27AE60"/>
+                </a:solidFill>
+                <a:latin typeface="Calibri"/>
+              </a:defRPr>
+            </a:pPr>
+            <a:r>
+              <a:t>Knowledge Sharing</a:t>
             </a:r>
           </a:p>
         </p:txBody>
@@ -5296,29 +8194,29 @@
         <p:spPr>
           <a:xfrm>
             <a:off x="1097280" y="2103120"/>
-            <a:ext cx="2743200" cy="548640"/>
-          </a:xfrm>
-          <a:prstGeom prst="rect">
-            <a:avLst/>
-          </a:prstGeom>
-          <a:noFill/>
-        </p:spPr>
-        <p:txBody>
-          <a:bodyPr wrap="square">
-            <a:spAutoFit/>
-          </a:bodyPr>
-          <a:lstStyle/>
-          <a:p>
-            <a:pPr algn="l">
-              <a:defRPr sz="2800" b="1" i="0">
-                <a:solidFill>
-                  <a:srgbClr val="2196F3"/>
-                </a:solidFill>
-                <a:latin typeface="Calibri"/>
-              </a:defRPr>
-            </a:pPr>
-            <a:r>
-              <a:t>30</a:t>
+            <a:ext cx="457200" cy="365760"/>
+          </a:xfrm>
+          <a:prstGeom prst="rect">
+            <a:avLst/>
+          </a:prstGeom>
+          <a:noFill/>
+        </p:spPr>
+        <p:txBody>
+          <a:bodyPr wrap="square">
+            <a:spAutoFit/>
+          </a:bodyPr>
+          <a:lstStyle/>
+          <a:p>
+            <a:pPr algn="l">
+              <a:defRPr sz="2200" b="1" i="0">
+                <a:solidFill>
+                  <a:srgbClr val="27AE60"/>
+                </a:solidFill>
+                <a:latin typeface="Calibri"/>
+              </a:defRPr>
+            </a:pPr>
+            <a:r>
+              <a:t>01</a:t>
             </a:r>
           </a:p>
         </p:txBody>
@@ -5331,22 +8229,58 @@
         </p:nvSpPr>
         <p:spPr>
           <a:xfrm>
-            <a:off x="1097280" y="2651760"/>
-            <a:ext cx="9966960" cy="365760"/>
-          </a:xfrm>
-          <a:prstGeom prst="rect">
-            <a:avLst/>
-          </a:prstGeom>
-          <a:noFill/>
-        </p:spPr>
-        <p:txBody>
-          <a:bodyPr wrap="square">
-            <a:spAutoFit/>
-          </a:bodyPr>
-          <a:lstStyle/>
-          <a:p>
-            <a:pPr algn="l">
-              <a:defRPr sz="1400" b="0" i="0">
+            <a:off x="1737360" y="2103120"/>
+            <a:ext cx="9326880" cy="365760"/>
+          </a:xfrm>
+          <a:prstGeom prst="rect">
+            <a:avLst/>
+          </a:prstGeom>
+          <a:noFill/>
+        </p:spPr>
+        <p:txBody>
+          <a:bodyPr wrap="square">
+            <a:spAutoFit/>
+          </a:bodyPr>
+          <a:lstStyle/>
+          <a:p>
+            <a:pPr algn="l">
+              <a:defRPr sz="1600" b="1" i="0">
+                <a:solidFill>
+                  <a:srgbClr val="FFFFFF"/>
+                </a:solidFill>
+                <a:latin typeface="Calibri"/>
+              </a:defRPr>
+            </a:pPr>
+            <a:r>
+              <a:t>The Speaking Coach: Communication Mastery</a:t>
+            </a:r>
+          </a:p>
+        </p:txBody>
+      </p:sp>
+      <p:sp>
+        <p:nvSpPr>
+          <p:cNvPr id="7" name="TextBox 6"/>
+          <p:cNvSpPr txBox="1"/>
+          <p:nvPr/>
+        </p:nvSpPr>
+        <p:spPr>
+          <a:xfrm>
+            <a:off x="1737360" y="2423160"/>
+            <a:ext cx="9326880" cy="365760"/>
+          </a:xfrm>
+          <a:prstGeom prst="rect">
+            <a:avLst/>
+          </a:prstGeom>
+          <a:noFill/>
+        </p:spPr>
+        <p:txBody>
+          <a:bodyPr wrap="square">
+            <a:spAutoFit/>
+          </a:bodyPr>
+          <a:lstStyle/>
+          <a:p>
+            <a:pPr algn="l">
+              <a:defRPr sz="1200" b="0" i="0">
                 <a:solidFill>
                   <a:srgbClr val="E2E2EA"/>
                 </a:solidFill>
@@ -5354,43 +8288,7 @@
               </a:defRPr>
             </a:pPr>
             <a:r>
-              <a:t>from Gleb Krahotkin</a:t>
-            </a:r>
-          </a:p>
-        </p:txBody>
-      </p:sp>
-      <p:sp>
-        <p:nvSpPr>
-          <p:cNvPr id="7" name="TextBox 6"/>
-          <p:cNvSpPr txBox="1"/>
-          <p:nvPr/>
-        </p:nvSpPr>
-        <p:spPr>
-          <a:xfrm>
-            <a:off x="1097280" y="3108960"/>
-            <a:ext cx="9966960" cy="365760"/>
-          </a:xfrm>
-          <a:prstGeom prst="rect">
-            <a:avLst/>
-          </a:prstGeom>
-          <a:noFill/>
-        </p:spPr>
-        <p:txBody>
-          <a:bodyPr wrap="square">
-            <a:spAutoFit/>
-          </a:bodyPr>
-          <a:lstStyle/>
-          <a:p>
-            <a:pPr algn="l">
-              <a:defRPr sz="1400" b="1" i="0">
-                <a:solidFill>
-                  <a:srgbClr val="FFFFFF"/>
-                </a:solidFill>
-                <a:latin typeface="Calibri"/>
-              </a:defRPr>
-            </a:pPr>
-            <a:r>
-              <a:t>to: Hierman Pelekh</a:t>
+              <a:t>Essential insights on powerful communication and avoiding weak language patterns</a:t>
             </a:r>
           </a:p>
         </p:txBody>
@@ -5403,30 +8301,30 @@
         </p:nvSpPr>
         <p:spPr>
           <a:xfrm>
-            <a:off x="1097280" y="3749039"/>
-            <a:ext cx="9966960" cy="1097280"/>
-          </a:xfrm>
-          <a:prstGeom prst="rect">
-            <a:avLst/>
-          </a:prstGeom>
-          <a:noFill/>
-        </p:spPr>
-        <p:txBody>
-          <a:bodyPr wrap="square">
-            <a:spAutoFit/>
-          </a:bodyPr>
-          <a:lstStyle/>
-          <a:p>
-            <a:pPr algn="l">
-              <a:defRPr sz="1500" b="0" i="1">
-                <a:solidFill>
-                  <a:srgbClr val="E2E2EA"/>
-                </a:solidFill>
-                <a:latin typeface="Calibri"/>
-              </a:defRPr>
-            </a:pPr>
-            <a:r>
-              <a:t>"Amazing teamwork and collaborative spirit"</a:t>
+            <a:off x="1737360" y="2743200"/>
+            <a:ext cx="9326880" cy="274320"/>
+          </a:xfrm>
+          <a:prstGeom prst="rect">
+            <a:avLst/>
+          </a:prstGeom>
+          <a:noFill/>
+        </p:spPr>
+        <p:txBody>
+          <a:bodyPr wrap="square">
+            <a:spAutoFit/>
+          </a:bodyPr>
+          <a:lstStyle/>
+          <a:p>
+            <a:pPr algn="l">
+              <a:defRPr sz="1100" b="0" i="0">
+                <a:solidFill>
+                  <a:srgbClr val="8F95A3"/>
+                </a:solidFill>
+                <a:latin typeface="Calibri"/>
+              </a:defRPr>
+            </a:pPr>
+            <a:r>
+              <a:t>Shared by Maria Plendukova · 2</a:t>
             </a:r>
           </a:p>
         </p:txBody>
@@ -5439,30 +8337,30 @@
         </p:nvSpPr>
         <p:spPr>
           <a:xfrm>
-            <a:off x="1097280" y="5120640"/>
-            <a:ext cx="9966960" cy="457200"/>
-          </a:xfrm>
-          <a:prstGeom prst="rect">
-            <a:avLst/>
-          </a:prstGeom>
-          <a:noFill/>
-        </p:spPr>
-        <p:txBody>
-          <a:bodyPr wrap="square">
-            <a:spAutoFit/>
-          </a:bodyPr>
-          <a:lstStyle/>
-          <a:p>
-            <a:pPr algn="l">
-              <a:defRPr sz="1200" b="1" i="0">
-                <a:solidFill>
-                  <a:srgbClr val="2196F3"/>
-                </a:solidFill>
-                <a:latin typeface="Calibri"/>
-              </a:defRPr>
-            </a:pPr>
-            <a:r>
-              <a:t>Teamwork · Collaboration</a:t>
+            <a:off x="1097280" y="5943600"/>
+            <a:ext cx="9966960" cy="274320"/>
+          </a:xfrm>
+          <a:prstGeom prst="rect">
+            <a:avLst/>
+          </a:prstGeom>
+          <a:noFill/>
+        </p:spPr>
+        <p:txBody>
+          <a:bodyPr wrap="square">
+            <a:spAutoFit/>
+          </a:bodyPr>
+          <a:lstStyle/>
+          <a:p>
+            <a:pPr algn="l">
+              <a:defRPr sz="1100" b="0" i="0">
+                <a:solidFill>
+                  <a:srgbClr val="5C6270"/>
+                </a:solidFill>
+                <a:latin typeface="Calibri"/>
+              </a:defRPr>
+            </a:pPr>
+            <a:r>
+              <a:t>#general-chat</a:t>
             </a:r>
           </a:p>
         </p:txBody>
@@ -5508,7 +8406,7 @@
             <a:avLst/>
           </a:prstGeom>
           <a:solidFill>
-            <a:srgbClr val="607D8B"/>
+            <a:srgbClr val="8E44AD"/>
           </a:solidFill>
           <a:ln>
             <a:noFill/>
@@ -5561,13 +8459,13 @@
             <a:pPr algn="l">
               <a:defRPr sz="1000" b="1">
                 <a:solidFill>
-                  <a:srgbClr val="607D8B"/>
-                </a:solidFill>
-                <a:latin typeface="Calibri"/>
-              </a:defRPr>
-            </a:pPr>
-            <a:r>
-              <a:t>📊  MILESTONE</a:t>
+                  <a:srgbClr val="8E44AD"/>
+                </a:solidFill>
+                <a:latin typeface="Calibri"/>
+              </a:defRPr>
+            </a:pPr>
+            <a:r>
+              <a:t>📖  WEEKLY RITUAL</a:t>
             </a:r>
           </a:p>
         </p:txBody>
@@ -5597,13 +8495,13 @@
             <a:pPr algn="l">
               <a:defRPr sz="3200" b="1" i="0">
                 <a:solidFill>
-                  <a:srgbClr val="607D8B"/>
-                </a:solidFill>
-                <a:latin typeface="Calibri"/>
-              </a:defRPr>
-            </a:pPr>
-            <a:r>
-              <a:t>Core Values Initiative</a:t>
+                  <a:srgbClr val="8E44AD"/>
+                </a:solidFill>
+                <a:latin typeface="Calibri"/>
+              </a:defRPr>
+            </a:pPr>
+            <a:r>
+              <a:t>Reading Club Launch</a:t>
             </a:r>
           </a:p>
         </p:txBody>
@@ -5617,29 +8515,29 @@
         <p:spPr>
           <a:xfrm>
             <a:off x="1097280" y="2103120"/>
-            <a:ext cx="4572000" cy="822960"/>
-          </a:xfrm>
-          <a:prstGeom prst="rect">
-            <a:avLst/>
-          </a:prstGeom>
-          <a:noFill/>
-        </p:spPr>
-        <p:txBody>
-          <a:bodyPr wrap="square">
-            <a:spAutoFit/>
-          </a:bodyPr>
-          <a:lstStyle/>
-          <a:p>
-            <a:pPr algn="l">
-              <a:defRPr sz="5200" b="1" i="0">
-                <a:solidFill>
-                  <a:srgbClr val="607D8B"/>
-                </a:solidFill>
-                <a:latin typeface="Calibri"/>
-              </a:defRPr>
-            </a:pPr>
-            <a:r>
-              <a:t>100</a:t>
+            <a:ext cx="9966960" cy="457200"/>
+          </a:xfrm>
+          <a:prstGeom prst="rect">
+            <a:avLst/>
+          </a:prstGeom>
+          <a:noFill/>
+        </p:spPr>
+        <p:txBody>
+          <a:bodyPr wrap="square">
+            <a:spAutoFit/>
+          </a:bodyPr>
+          <a:lstStyle/>
+          <a:p>
+            <a:pPr algn="l">
+              <a:defRPr sz="1800" b="1" i="0">
+                <a:solidFill>
+                  <a:srgbClr val="FFFFFF"/>
+                </a:solidFill>
+                <a:latin typeface="Calibri"/>
+              </a:defRPr>
+            </a:pPr>
+            <a:r>
+              <a:t>The 4 Disciplines of Execution</a:t>
             </a:r>
           </a:p>
         </p:txBody>
@@ -5652,8 +8550,116 @@
         </p:nvSpPr>
         <p:spPr>
           <a:xfrm>
-            <a:off x="1097280" y="2926080"/>
-            <a:ext cx="4572000" cy="365760"/>
+            <a:off x="1371600" y="2926080"/>
+            <a:ext cx="9418320" cy="548640"/>
+          </a:xfrm>
+          <a:prstGeom prst="rect">
+            <a:avLst/>
+          </a:prstGeom>
+          <a:noFill/>
+        </p:spPr>
+        <p:txBody>
+          <a:bodyPr wrap="square">
+            <a:spAutoFit/>
+          </a:bodyPr>
+          <a:lstStyle/>
+          <a:p>
+            <a:pPr algn="l">
+              <a:defRPr sz="1400" b="0" i="0">
+                <a:solidFill>
+                  <a:srgbClr val="E2E2EA"/>
+                </a:solidFill>
+                <a:latin typeface="Calibri"/>
+              </a:defRPr>
+            </a:pPr>
+            <a:r>
+              <a:t>Join Anna's new reading club</a:t>
+            </a:r>
+          </a:p>
+        </p:txBody>
+      </p:sp>
+      <p:sp>
+        <p:nvSpPr>
+          <p:cNvPr id="7" name="TextBox 6"/>
+          <p:cNvSpPr txBox="1"/>
+          <p:nvPr/>
+        </p:nvSpPr>
+        <p:spPr>
+          <a:xfrm>
+            <a:off x="1371600" y="3657600"/>
+            <a:ext cx="9418320" cy="548640"/>
+          </a:xfrm>
+          <a:prstGeom prst="rect">
+            <a:avLst/>
+          </a:prstGeom>
+          <a:noFill/>
+        </p:spPr>
+        <p:txBody>
+          <a:bodyPr wrap="square">
+            <a:spAutoFit/>
+          </a:bodyPr>
+          <a:lstStyle/>
+          <a:p>
+            <a:pPr algn="l">
+              <a:defRPr sz="1400" b="0" i="0">
+                <a:solidFill>
+                  <a:srgbClr val="E2E2EA"/>
+                </a:solidFill>
+                <a:latin typeface="Calibri"/>
+              </a:defRPr>
+            </a:pPr>
+            <a:r>
+              <a:t>Focus on execution excellence this quarter</a:t>
+            </a:r>
+          </a:p>
+        </p:txBody>
+      </p:sp>
+      <p:sp>
+        <p:nvSpPr>
+          <p:cNvPr id="8" name="TextBox 7"/>
+          <p:cNvSpPr txBox="1"/>
+          <p:nvPr/>
+        </p:nvSpPr>
+        <p:spPr>
+          <a:xfrm>
+            <a:off x="1097280" y="4754880"/>
+            <a:ext cx="9966960" cy="731520"/>
+          </a:xfrm>
+          <a:prstGeom prst="rect">
+            <a:avLst/>
+          </a:prstGeom>
+          <a:noFill/>
+        </p:spPr>
+        <p:txBody>
+          <a:bodyPr wrap="square">
+            <a:spAutoFit/>
+          </a:bodyPr>
+          <a:lstStyle/>
+          <a:p>
+            <a:pPr algn="l">
+              <a:defRPr sz="1500" b="0" i="1">
+                <a:solidFill>
+                  <a:srgbClr val="E2E2EA"/>
+                </a:solidFill>
+                <a:latin typeface="Calibri"/>
+              </a:defRPr>
+            </a:pPr>
+            <a:r>
+              <a:t>CONTINUOUS LEARNING</a:t>
+            </a:r>
+          </a:p>
+        </p:txBody>
+      </p:sp>
+      <p:sp>
+        <p:nvSpPr>
+          <p:cNvPr id="9" name="TextBox 8"/>
+          <p:cNvSpPr txBox="1"/>
+          <p:nvPr/>
+        </p:nvSpPr>
+        <p:spPr>
+          <a:xfrm>
+            <a:off x="1097280" y="5760720"/>
+            <a:ext cx="9966960" cy="274320"/>
           </a:xfrm>
           <a:prstGeom prst="rect">
             <a:avLst/>
@@ -5669,85 +8675,13 @@
             <a:pPr algn="l">
               <a:defRPr sz="1100" b="0" i="0">
                 <a:solidFill>
-                  <a:srgbClr val="8F95A3"/>
-                </a:solidFill>
-                <a:latin typeface="Calibri"/>
-              </a:defRPr>
-            </a:pPr>
-            <a:r>
-              <a:t>% commitment to values-driven decisions</a:t>
-            </a:r>
-          </a:p>
-        </p:txBody>
-      </p:sp>
-      <p:sp>
-        <p:nvSpPr>
-          <p:cNvPr id="7" name="TextBox 6"/>
-          <p:cNvSpPr txBox="1"/>
-          <p:nvPr/>
-        </p:nvSpPr>
-        <p:spPr>
-          <a:xfrm>
-            <a:off x="1097280" y="3566160"/>
-            <a:ext cx="9966960" cy="457200"/>
-          </a:xfrm>
-          <a:prstGeom prst="rect">
-            <a:avLst/>
-          </a:prstGeom>
-          <a:noFill/>
-        </p:spPr>
-        <p:txBody>
-          <a:bodyPr wrap="square">
-            <a:spAutoFit/>
-          </a:bodyPr>
-          <a:lstStyle/>
-          <a:p>
-            <a:pPr algn="l">
-              <a:defRPr sz="1800" b="1" i="0">
-                <a:solidFill>
-                  <a:srgbClr val="FFFFFF"/>
-                </a:solidFill>
-                <a:latin typeface="Calibri"/>
-              </a:defRPr>
-            </a:pPr>
-            <a:r>
-              <a:t>CV Health Rate Implementation</a:t>
-            </a:r>
-          </a:p>
-        </p:txBody>
-      </p:sp>
-      <p:sp>
-        <p:nvSpPr>
-          <p:cNvPr id="8" name="TextBox 7"/>
-          <p:cNvSpPr txBox="1"/>
-          <p:nvPr/>
-        </p:nvSpPr>
-        <p:spPr>
-          <a:xfrm>
-            <a:off x="1097280" y="4206240"/>
-            <a:ext cx="9966960" cy="1371600"/>
-          </a:xfrm>
-          <a:prstGeom prst="rect">
-            <a:avLst/>
-          </a:prstGeom>
-          <a:noFill/>
-        </p:spPr>
-        <p:txBody>
-          <a:bodyPr wrap="square">
-            <a:spAutoFit/>
-          </a:bodyPr>
-          <a:lstStyle/>
-          <a:p>
-            <a:pPr algn="l">
-              <a:defRPr sz="1500" b="0" i="0">
-                <a:solidFill>
-                  <a:srgbClr val="E2E2EA"/>
-                </a:solidFill>
-                <a:latin typeface="Calibri"/>
-              </a:defRPr>
-            </a:pPr>
-            <a:r>
-              <a:t>Pavel Golubev outlined our strategic initiative to transform Core Values and Leadership Principles into operational constraints and decision-making guardrails.</a:t>
+                  <a:srgbClr val="5C6270"/>
+                </a:solidFill>
+                <a:latin typeface="Calibri"/>
+              </a:defRPr>
+            </a:pPr>
+            <a:r>
+              <a:t>#general</a:t>
             </a:r>
           </a:p>
         </p:txBody>
@@ -5793,7 +8727,7 @@
             <a:avLst/>
           </a:prstGeom>
           <a:solidFill>
-            <a:srgbClr val="795548"/>
+            <a:srgbClr val="F39C12"/>
           </a:solidFill>
           <a:ln>
             <a:noFill/>
@@ -5846,13 +8780,13 @@
             <a:pPr algn="l">
               <a:defRPr sz="1000" b="1">
                 <a:solidFill>
-                  <a:srgbClr val="795548"/>
-                </a:solidFill>
-                <a:latin typeface="Calibri"/>
-              </a:defRPr>
-            </a:pPr>
-            <a:r>
-              <a:t>📚  RECOMMENDED</a:t>
+                  <a:srgbClr val="F39C12"/>
+                </a:solidFill>
+                <a:latin typeface="Calibri"/>
+              </a:defRPr>
+            </a:pPr>
+            <a:r>
+              <a:t>🎯  CLAPS</a:t>
             </a:r>
           </a:p>
         </p:txBody>
@@ -5882,13 +8816,13 @@
             <a:pPr algn="l">
               <a:defRPr sz="3200" b="1" i="0">
                 <a:solidFill>
-                  <a:srgbClr val="795548"/>
-                </a:solidFill>
-                <a:latin typeface="Calibri"/>
-              </a:defRPr>
-            </a:pPr>
-            <a:r>
-              <a:t>Learn &amp; Grow</a:t>
+                  <a:srgbClr val="F39C12"/>
+                </a:solidFill>
+                <a:latin typeface="Calibri"/>
+              </a:defRPr>
+            </a:pPr>
+            <a:r>
+              <a:t>Team Collaboration</a:t>
             </a:r>
           </a:p>
         </p:txBody>
@@ -5902,29 +8836,29 @@
         <p:spPr>
           <a:xfrm>
             <a:off x="1097280" y="2103120"/>
-            <a:ext cx="457200" cy="365760"/>
-          </a:xfrm>
-          <a:prstGeom prst="rect">
-            <a:avLst/>
-          </a:prstGeom>
-          <a:noFill/>
-        </p:spPr>
-        <p:txBody>
-          <a:bodyPr wrap="square">
-            <a:spAutoFit/>
-          </a:bodyPr>
-          <a:lstStyle/>
-          <a:p>
-            <a:pPr algn="l">
-              <a:defRPr sz="2200" b="1" i="0">
-                <a:solidFill>
-                  <a:srgbClr val="795548"/>
-                </a:solidFill>
-                <a:latin typeface="Calibri"/>
-              </a:defRPr>
-            </a:pPr>
-            <a:r>
-              <a:t>01</a:t>
+            <a:ext cx="2743200" cy="548640"/>
+          </a:xfrm>
+          <a:prstGeom prst="rect">
+            <a:avLst/>
+          </a:prstGeom>
+          <a:noFill/>
+        </p:spPr>
+        <p:txBody>
+          <a:bodyPr wrap="square">
+            <a:spAutoFit/>
+          </a:bodyPr>
+          <a:lstStyle/>
+          <a:p>
+            <a:pPr algn="l">
+              <a:defRPr sz="2800" b="1" i="0">
+                <a:solidFill>
+                  <a:srgbClr val="F39C12"/>
+                </a:solidFill>
+                <a:latin typeface="Calibri"/>
+              </a:defRPr>
+            </a:pPr>
+            <a:r>
+              <a:t>40</a:t>
             </a:r>
           </a:p>
         </p:txBody>
@@ -5937,22 +8871,58 @@
         </p:nvSpPr>
         <p:spPr>
           <a:xfrm>
-            <a:off x="1737360" y="2103120"/>
-            <a:ext cx="9326880" cy="365760"/>
-          </a:xfrm>
-          <a:prstGeom prst="rect">
-            <a:avLst/>
-          </a:prstGeom>
-          <a:noFill/>
-        </p:spPr>
-        <p:txBody>
-          <a:bodyPr wrap="square">
-            <a:spAutoFit/>
-          </a:bodyPr>
-          <a:lstStyle/>
-          <a:p>
-            <a:pPr algn="l">
-              <a:defRPr sz="1600" b="1" i="0">
+            <a:off x="1097280" y="2651760"/>
+            <a:ext cx="9966960" cy="365760"/>
+          </a:xfrm>
+          <a:prstGeom prst="rect">
+            <a:avLst/>
+          </a:prstGeom>
+          <a:noFill/>
+        </p:spPr>
+        <p:txBody>
+          <a:bodyPr wrap="square">
+            <a:spAutoFit/>
+          </a:bodyPr>
+          <a:lstStyle/>
+          <a:p>
+            <a:pPr algn="l">
+              <a:defRPr sz="1400" b="0" i="0">
+                <a:solidFill>
+                  <a:srgbClr val="E2E2EA"/>
+                </a:solidFill>
+                <a:latin typeface="Calibri"/>
+              </a:defRPr>
+            </a:pPr>
+            <a:r>
+              <a:t>from Anastasia Sokolova</a:t>
+            </a:r>
+          </a:p>
+        </p:txBody>
+      </p:sp>
+      <p:sp>
+        <p:nvSpPr>
+          <p:cNvPr id="7" name="TextBox 6"/>
+          <p:cNvSpPr txBox="1"/>
+          <p:nvPr/>
+        </p:nvSpPr>
+        <p:spPr>
+          <a:xfrm>
+            <a:off x="1097280" y="3108960"/>
+            <a:ext cx="9966960" cy="365760"/>
+          </a:xfrm>
+          <a:prstGeom prst="rect">
+            <a:avLst/>
+          </a:prstGeom>
+          <a:noFill/>
+        </p:spPr>
+        <p:txBody>
+          <a:bodyPr wrap="square">
+            <a:spAutoFit/>
+          </a:bodyPr>
+          <a:lstStyle/>
+          <a:p>
+            <a:pPr algn="l">
+              <a:defRPr sz="1400" b="1" i="0">
                 <a:solidFill>
                   <a:srgbClr val="FFFFFF"/>
                 </a:solidFill>
@@ -5960,35 +8930,35 @@
               </a:defRPr>
             </a:pPr>
             <a:r>
-              <a:t>Coolify Deployment Guide</a:t>
-            </a:r>
-          </a:p>
-        </p:txBody>
-      </p:sp>
-      <p:sp>
-        <p:nvSpPr>
-          <p:cNvPr id="7" name="TextBox 6"/>
-          <p:cNvSpPr txBox="1"/>
-          <p:nvPr/>
-        </p:nvSpPr>
-        <p:spPr>
-          <a:xfrm>
-            <a:off x="1737360" y="2423160"/>
-            <a:ext cx="9326880" cy="365760"/>
-          </a:xfrm>
-          <a:prstGeom prst="rect">
-            <a:avLst/>
-          </a:prstGeom>
-          <a:noFill/>
-        </p:spPr>
-        <p:txBody>
-          <a:bodyPr wrap="square">
-            <a:spAutoFit/>
-          </a:bodyPr>
-          <a:lstStyle/>
-          <a:p>
-            <a:pPr algn="l">
-              <a:defRPr sz="1200" b="0" i="0">
+              <a:t>to: Sasha Sakovich</a:t>
+            </a:r>
+          </a:p>
+        </p:txBody>
+      </p:sp>
+      <p:sp>
+        <p:nvSpPr>
+          <p:cNvPr id="8" name="TextBox 7"/>
+          <p:cNvSpPr txBox="1"/>
+          <p:nvPr/>
+        </p:nvSpPr>
+        <p:spPr>
+          <a:xfrm>
+            <a:off x="1097280" y="3749039"/>
+            <a:ext cx="9966960" cy="1097280"/>
+          </a:xfrm>
+          <a:prstGeom prst="rect">
+            <a:avLst/>
+          </a:prstGeom>
+          <a:noFill/>
+        </p:spPr>
+        <p:txBody>
+          <a:bodyPr wrap="square">
+            <a:spAutoFit/>
+          </a:bodyPr>
+          <a:lstStyle/>
+          <a:p>
+            <a:pPr algn="l">
+              <a:defRPr sz="1500" b="0" i="1">
                 <a:solidFill>
                   <a:srgbClr val="E2E2EA"/>
                 </a:solidFill>
@@ -5996,43 +8966,7 @@
               </a:defRPr>
             </a:pPr>
             <a:r>
-              <a:t>Complete guide on using our new one-click deployment service</a:t>
-            </a:r>
-          </a:p>
-        </p:txBody>
-      </p:sp>
-      <p:sp>
-        <p:nvSpPr>
-          <p:cNvPr id="8" name="TextBox 7"/>
-          <p:cNvSpPr txBox="1"/>
-          <p:nvPr/>
-        </p:nvSpPr>
-        <p:spPr>
-          <a:xfrm>
-            <a:off x="1737360" y="2743200"/>
-            <a:ext cx="9326880" cy="274320"/>
-          </a:xfrm>
-          <a:prstGeom prst="rect">
-            <a:avLst/>
-          </a:prstGeom>
-          <a:noFill/>
-        </p:spPr>
-        <p:txBody>
-          <a:bodyPr wrap="square">
-            <a:spAutoFit/>
-          </a:bodyPr>
-          <a:lstStyle/>
-          <a:p>
-            <a:pPr algn="l">
-              <a:defRPr sz="1100" b="0" i="0">
-                <a:solidFill>
-                  <a:srgbClr val="8F95A3"/>
-                </a:solidFill>
-                <a:latin typeface="Calibri"/>
-              </a:defRPr>
-            </a:pPr>
-            <a:r>
-              <a:t>Shared by Gleb Krahotkin · 98</a:t>
+              <a:t>"Outstanding teamwork and results delivery"</a:t>
             </a:r>
           </a:p>
         </p:txBody>
@@ -6045,174 +8979,30 @@
         </p:nvSpPr>
         <p:spPr>
           <a:xfrm>
-            <a:off x="1097280" y="3291839"/>
-            <a:ext cx="457200" cy="365760"/>
-          </a:xfrm>
-          <a:prstGeom prst="rect">
-            <a:avLst/>
-          </a:prstGeom>
-          <a:noFill/>
-        </p:spPr>
-        <p:txBody>
-          <a:bodyPr wrap="square">
-            <a:spAutoFit/>
-          </a:bodyPr>
-          <a:lstStyle/>
-          <a:p>
-            <a:pPr algn="l">
-              <a:defRPr sz="2200" b="1" i="0">
-                <a:solidFill>
-                  <a:srgbClr val="795548"/>
-                </a:solidFill>
-                <a:latin typeface="Calibri"/>
-              </a:defRPr>
-            </a:pPr>
-            <a:r>
-              <a:t>02</a:t>
-            </a:r>
-          </a:p>
-        </p:txBody>
-      </p:sp>
-      <p:sp>
-        <p:nvSpPr>
-          <p:cNvPr id="10" name="TextBox 9"/>
-          <p:cNvSpPr txBox="1"/>
-          <p:nvPr/>
-        </p:nvSpPr>
-        <p:spPr>
-          <a:xfrm>
-            <a:off x="1737360" y="3291839"/>
-            <a:ext cx="9326880" cy="365760"/>
-          </a:xfrm>
-          <a:prstGeom prst="rect">
-            <a:avLst/>
-          </a:prstGeom>
-          <a:noFill/>
-        </p:spPr>
-        <p:txBody>
-          <a:bodyPr wrap="square">
-            <a:spAutoFit/>
-          </a:bodyPr>
-          <a:lstStyle/>
-          <a:p>
-            <a:pPr algn="l">
-              <a:defRPr sz="1600" b="1" i="0">
-                <a:solidFill>
-                  <a:srgbClr val="FFFFFF"/>
-                </a:solidFill>
-                <a:latin typeface="Calibri"/>
-              </a:defRPr>
-            </a:pPr>
-            <a:r>
-              <a:t>Fraud Detection Deep Dive</a:t>
-            </a:r>
-          </a:p>
-        </p:txBody>
-      </p:sp>
-      <p:sp>
-        <p:nvSpPr>
-          <p:cNvPr id="11" name="TextBox 10"/>
-          <p:cNvSpPr txBox="1"/>
-          <p:nvPr/>
-        </p:nvSpPr>
-        <p:spPr>
-          <a:xfrm>
-            <a:off x="1737360" y="3611879"/>
-            <a:ext cx="9326880" cy="365760"/>
-          </a:xfrm>
-          <a:prstGeom prst="rect">
-            <a:avLst/>
-          </a:prstGeom>
-          <a:noFill/>
-        </p:spPr>
-        <p:txBody>
-          <a:bodyPr wrap="square">
-            <a:spAutoFit/>
-          </a:bodyPr>
-          <a:lstStyle/>
-          <a:p>
-            <a:pPr algn="l">
-              <a:defRPr sz="1200" b="0" i="0">
-                <a:solidFill>
-                  <a:srgbClr val="E2E2EA"/>
-                </a:solidFill>
-                <a:latin typeface="Calibri"/>
-              </a:defRPr>
-            </a:pPr>
-            <a:r>
-              <a:t>Technical insights from our 11th Lunch &amp; Learn session</a:t>
-            </a:r>
-          </a:p>
-        </p:txBody>
-      </p:sp>
-      <p:sp>
-        <p:nvSpPr>
-          <p:cNvPr id="12" name="TextBox 11"/>
-          <p:cNvSpPr txBox="1"/>
-          <p:nvPr/>
-        </p:nvSpPr>
-        <p:spPr>
-          <a:xfrm>
-            <a:off x="1737360" y="3931920"/>
-            <a:ext cx="9326880" cy="274320"/>
-          </a:xfrm>
-          <a:prstGeom prst="rect">
-            <a:avLst/>
-          </a:prstGeom>
-          <a:noFill/>
-        </p:spPr>
-        <p:txBody>
-          <a:bodyPr wrap="square">
-            <a:spAutoFit/>
-          </a:bodyPr>
-          <a:lstStyle/>
-          <a:p>
-            <a:pPr algn="l">
-              <a:defRPr sz="1100" b="0" i="0">
-                <a:solidFill>
-                  <a:srgbClr val="8F95A3"/>
-                </a:solidFill>
-                <a:latin typeface="Calibri"/>
-              </a:defRPr>
-            </a:pPr>
-            <a:r>
-              <a:t>Shared by Timofey Levanov · 28</a:t>
-            </a:r>
-          </a:p>
-        </p:txBody>
-      </p:sp>
-      <p:sp>
-        <p:nvSpPr>
-          <p:cNvPr id="13" name="TextBox 12"/>
-          <p:cNvSpPr txBox="1"/>
-          <p:nvPr/>
-        </p:nvSpPr>
-        <p:spPr>
-          <a:xfrm>
-            <a:off x="1097280" y="5943600"/>
-            <a:ext cx="9966960" cy="274320"/>
-          </a:xfrm>
-          <a:prstGeom prst="rect">
-            <a:avLst/>
-          </a:prstGeom>
-          <a:noFill/>
-        </p:spPr>
-        <p:txBody>
-          <a:bodyPr wrap="square">
-            <a:spAutoFit/>
-          </a:bodyPr>
-          <a:lstStyle/>
-          <a:p>
-            <a:pPr algn="l">
-              <a:defRPr sz="1100" b="0" i="0">
-                <a:solidFill>
-                  <a:srgbClr val="5C6270"/>
-                </a:solidFill>
-                <a:latin typeface="Calibri"/>
-              </a:defRPr>
-            </a:pPr>
-            <a:r>
-              <a:t>general</a:t>
+            <a:off x="1097280" y="5120640"/>
+            <a:ext cx="9966960" cy="457200"/>
+          </a:xfrm>
+          <a:prstGeom prst="rect">
+            <a:avLst/>
+          </a:prstGeom>
+          <a:noFill/>
+        </p:spPr>
+        <p:txBody>
+          <a:bodyPr wrap="square">
+            <a:spAutoFit/>
+          </a:bodyPr>
+          <a:lstStyle/>
+          <a:p>
+            <a:pPr algn="l">
+              <a:defRPr sz="1200" b="1" i="0">
+                <a:solidFill>
+                  <a:srgbClr val="F39C12"/>
+                </a:solidFill>
+                <a:latin typeface="Calibri"/>
+              </a:defRPr>
+            </a:pPr>
+            <a:r>
+              <a:t>TEAMWORK · RESULTS</a:t>
             </a:r>
           </a:p>
         </p:txBody>

</xml_diff>